<commit_message>
Added a project directory in the docs.
</commit_message>
<xml_diff>
--- a/units/unit04_procif/procif.pptx
+++ b/units/unit04_procif/procif.pptx
@@ -255,7 +255,7 @@
           <a:p>
             <a:fld id="{B7D6DDD3-D7E9-488B-B626-1E8285E424D8}" type="datetimeFigureOut">
               <a:rPr lang="en-US" smtClean="0"/>
-              <a:t>2/5/2026</a:t>
+              <a:t>2/22/2026</a:t>
             </a:fld>
             <a:endParaRPr lang="en-US"/>
           </a:p>
@@ -21535,7 +21535,7 @@
         </p:blipFill>
         <p:spPr bwMode="auto">
           <a:xfrm>
-            <a:off x="6237640" y="1806918"/>
+            <a:off x="6259463" y="1806918"/>
             <a:ext cx="647406" cy="609322"/>
           </a:xfrm>
           <a:prstGeom prst="rect">

</xml_diff>

<commit_message>
Started new documentation for the pysilicon flow
</commit_message>
<xml_diff>
--- a/units/unit04_procif/procif.pptx
+++ b/units/unit04_procif/procif.pptx
@@ -255,7 +255,7 @@
           <a:p>
             <a:fld id="{B7D6DDD3-D7E9-488B-B626-1E8285E424D8}" type="datetimeFigureOut">
               <a:rPr lang="en-US" smtClean="0"/>
-              <a:t>2/22/2026</a:t>
+              <a:t>3/31/2026</a:t>
             </a:fld>
             <a:endParaRPr lang="en-US"/>
           </a:p>
@@ -29755,58 +29755,6 @@
       </p:grpSpPr>
       <p:sp>
         <p:nvSpPr>
-          <p:cNvPr id="80" name="Rectangle 79">
-            <a:extLst>
-              <a:ext uri="{FF2B5EF4-FFF2-40B4-BE49-F238E27FC236}">
-                <a16:creationId xmlns:a16="http://schemas.microsoft.com/office/drawing/2014/main" id="{F6C25994-24DD-3620-4CAE-83A7CB132B95}"/>
-              </a:ext>
-            </a:extLst>
-          </p:cNvPr>
-          <p:cNvSpPr/>
-          <p:nvPr/>
-        </p:nvSpPr>
-        <p:spPr>
-          <a:xfrm>
-            <a:off x="3902065" y="2308781"/>
-            <a:ext cx="914317" cy="2640065"/>
-          </a:xfrm>
-          <a:prstGeom prst="rect">
-            <a:avLst/>
-          </a:prstGeom>
-          <a:solidFill>
-            <a:schemeClr val="accent1">
-              <a:lumMod val="20000"/>
-              <a:lumOff val="80000"/>
-            </a:schemeClr>
-          </a:solidFill>
-        </p:spPr>
-        <p:style>
-          <a:lnRef idx="2">
-            <a:schemeClr val="accent1">
-              <a:shade val="15000"/>
-            </a:schemeClr>
-          </a:lnRef>
-          <a:fillRef idx="1">
-            <a:schemeClr val="accent1"/>
-          </a:fillRef>
-          <a:effectRef idx="0">
-            <a:schemeClr val="accent1"/>
-          </a:effectRef>
-          <a:fontRef idx="minor">
-            <a:schemeClr val="lt1"/>
-          </a:fontRef>
-        </p:style>
-        <p:txBody>
-          <a:bodyPr rtlCol="0" anchor="ctr"/>
-          <a:lstStyle/>
-          <a:p>
-            <a:pPr algn="ctr"/>
-            <a:endParaRPr lang="en-US"/>
-          </a:p>
-        </p:txBody>
-      </p:sp>
-      <p:sp>
-        <p:nvSpPr>
           <p:cNvPr id="2" name="Title 1">
             <a:extLst>
               <a:ext uri="{FF2B5EF4-FFF2-40B4-BE49-F238E27FC236}">
@@ -30121,889 +30069,12 @@
           </a:p>
         </p:txBody>
       </p:sp>
-      <p:sp>
-        <p:nvSpPr>
-          <p:cNvPr id="5" name="Rectangle 4">
-            <a:extLst>
-              <a:ext uri="{FF2B5EF4-FFF2-40B4-BE49-F238E27FC236}">
-                <a16:creationId xmlns:a16="http://schemas.microsoft.com/office/drawing/2014/main" id="{95A1FAD5-8D48-A21C-8DF4-36148C5B302E}"/>
-              </a:ext>
-            </a:extLst>
-          </p:cNvPr>
-          <p:cNvSpPr/>
-          <p:nvPr/>
-        </p:nvSpPr>
-        <p:spPr>
-          <a:xfrm>
-            <a:off x="1679370" y="2802744"/>
-            <a:ext cx="914400" cy="914400"/>
-          </a:xfrm>
-          <a:prstGeom prst="rect">
-            <a:avLst/>
-          </a:prstGeom>
-          <a:solidFill>
-            <a:schemeClr val="accent5">
-              <a:lumMod val="20000"/>
-              <a:lumOff val="80000"/>
-            </a:schemeClr>
-          </a:solidFill>
-          <a:ln>
-            <a:solidFill>
-              <a:schemeClr val="accent5">
-                <a:lumMod val="75000"/>
-              </a:schemeClr>
-            </a:solidFill>
-          </a:ln>
-        </p:spPr>
-        <p:style>
-          <a:lnRef idx="2">
-            <a:schemeClr val="accent1">
-              <a:shade val="15000"/>
-            </a:schemeClr>
-          </a:lnRef>
-          <a:fillRef idx="1">
-            <a:schemeClr val="accent1"/>
-          </a:fillRef>
-          <a:effectRef idx="0">
-            <a:schemeClr val="accent1"/>
-          </a:effectRef>
-          <a:fontRef idx="minor">
-            <a:schemeClr val="lt1"/>
-          </a:fontRef>
-        </p:style>
-        <p:txBody>
-          <a:bodyPr rtlCol="0" anchor="ctr"/>
-          <a:lstStyle/>
-          <a:p>
-            <a:pPr algn="ctr"/>
-            <a:endParaRPr lang="en-US"/>
-          </a:p>
-        </p:txBody>
-      </p:sp>
-      <p:sp>
-        <p:nvSpPr>
-          <p:cNvPr id="6" name="Rectangle 5">
-            <a:extLst>
-              <a:ext uri="{FF2B5EF4-FFF2-40B4-BE49-F238E27FC236}">
-                <a16:creationId xmlns:a16="http://schemas.microsoft.com/office/drawing/2014/main" id="{55B9A0E3-C243-06FE-69F7-6765D2A1CD2A}"/>
-              </a:ext>
-            </a:extLst>
-          </p:cNvPr>
-          <p:cNvSpPr/>
-          <p:nvPr/>
-        </p:nvSpPr>
-        <p:spPr>
-          <a:xfrm>
-            <a:off x="5565006" y="2169329"/>
-            <a:ext cx="310060" cy="2882346"/>
-          </a:xfrm>
-          <a:prstGeom prst="rect">
-            <a:avLst/>
-          </a:prstGeom>
-          <a:solidFill>
-            <a:srgbClr val="CCFF99"/>
-          </a:solidFill>
-          <a:ln>
-            <a:solidFill>
-              <a:schemeClr val="accent3">
-                <a:lumMod val="75000"/>
-              </a:schemeClr>
-            </a:solidFill>
-          </a:ln>
-        </p:spPr>
-        <p:style>
-          <a:lnRef idx="2">
-            <a:schemeClr val="accent1">
-              <a:shade val="15000"/>
-            </a:schemeClr>
-          </a:lnRef>
-          <a:fillRef idx="1">
-            <a:schemeClr val="accent1"/>
-          </a:fillRef>
-          <a:effectRef idx="0">
-            <a:schemeClr val="accent1"/>
-          </a:effectRef>
-          <a:fontRef idx="minor">
-            <a:schemeClr val="lt1"/>
-          </a:fontRef>
-        </p:style>
-        <p:txBody>
-          <a:bodyPr rtlCol="0" anchor="ctr"/>
-          <a:lstStyle/>
-          <a:p>
-            <a:pPr algn="ctr"/>
-            <a:endParaRPr lang="en-US"/>
-          </a:p>
-        </p:txBody>
-      </p:sp>
-      <p:sp>
-        <p:nvSpPr>
-          <p:cNvPr id="7" name="Rectangle 6">
-            <a:extLst>
-              <a:ext uri="{FF2B5EF4-FFF2-40B4-BE49-F238E27FC236}">
-                <a16:creationId xmlns:a16="http://schemas.microsoft.com/office/drawing/2014/main" id="{89E19483-793F-2739-2D1F-E802903699E3}"/>
-              </a:ext>
-            </a:extLst>
-          </p:cNvPr>
-          <p:cNvSpPr/>
-          <p:nvPr/>
-        </p:nvSpPr>
-        <p:spPr>
-          <a:xfrm>
-            <a:off x="3911830" y="2899598"/>
-            <a:ext cx="914317" cy="304811"/>
-          </a:xfrm>
-          <a:prstGeom prst="rect">
-            <a:avLst/>
-          </a:prstGeom>
-        </p:spPr>
-        <p:style>
-          <a:lnRef idx="2">
-            <a:schemeClr val="accent1">
-              <a:shade val="15000"/>
-            </a:schemeClr>
-          </a:lnRef>
-          <a:fillRef idx="1">
-            <a:schemeClr val="accent1"/>
-          </a:fillRef>
-          <a:effectRef idx="0">
-            <a:schemeClr val="accent1"/>
-          </a:effectRef>
-          <a:fontRef idx="minor">
-            <a:schemeClr val="lt1"/>
-          </a:fontRef>
-        </p:style>
-        <p:txBody>
-          <a:bodyPr rtlCol="0" anchor="ctr"/>
-          <a:lstStyle/>
-          <a:p>
-            <a:pPr algn="ctr"/>
-            <a:endParaRPr lang="en-US"/>
-          </a:p>
-        </p:txBody>
-      </p:sp>
-      <mc:AlternateContent xmlns:mc="http://schemas.openxmlformats.org/markup-compatibility/2006" xmlns:a14="http://schemas.microsoft.com/office/drawing/2010/main">
-        <mc:Choice Requires="a14">
-          <p:sp>
-            <p:nvSpPr>
-              <p:cNvPr id="8" name="TextBox 7">
-                <a:extLst>
-                  <a:ext uri="{FF2B5EF4-FFF2-40B4-BE49-F238E27FC236}">
-                    <a16:creationId xmlns:a16="http://schemas.microsoft.com/office/drawing/2014/main" id="{D813B71A-C912-EBEC-25EA-1B920697ED87}"/>
-                  </a:ext>
-                </a:extLst>
-              </p:cNvPr>
-              <p:cNvSpPr txBox="1"/>
-              <p:nvPr/>
-            </p:nvSpPr>
-            <p:spPr>
-              <a:xfrm>
-                <a:off x="324438" y="2579880"/>
-                <a:ext cx="1334533" cy="584775"/>
-              </a:xfrm>
-              <a:prstGeom prst="rect">
-                <a:avLst/>
-              </a:prstGeom>
-              <a:noFill/>
-            </p:spPr>
-            <p:txBody>
-              <a:bodyPr wrap="none" rtlCol="0">
-                <a:spAutoFit/>
-              </a:bodyPr>
-              <a:lstStyle/>
-              <a:p>
-                <a:r>
-                  <a:rPr lang="en-US" sz="1600" dirty="0">
-                    <a:solidFill>
-                      <a:schemeClr val="accent6">
-                        <a:lumMod val="75000"/>
-                      </a:schemeClr>
-                    </a:solidFill>
-                  </a:rPr>
-                  <a:t>Address input</a:t>
-                </a:r>
-                <a:br>
-                  <a:rPr lang="en-US" sz="1600" dirty="0"/>
-                </a:br>
-                <a14:m>
-                  <m:oMath xmlns:m="http://schemas.openxmlformats.org/officeDocument/2006/math">
-                    <m:func>
-                      <m:funcPr>
-                        <m:ctrlPr>
-                          <a:rPr lang="en-US" sz="1600" b="0" i="1" smtClean="0">
-                            <a:latin typeface="Cambria Math" panose="02040503050406030204" pitchFamily="18" charset="0"/>
-                          </a:rPr>
-                        </m:ctrlPr>
-                      </m:funcPr>
-                      <m:fName>
-                        <m:sSub>
-                          <m:sSubPr>
-                            <m:ctrlPr>
-                              <a:rPr lang="en-US" sz="1600" b="0" i="1" smtClean="0">
-                                <a:latin typeface="Cambria Math" panose="02040503050406030204" pitchFamily="18" charset="0"/>
-                              </a:rPr>
-                            </m:ctrlPr>
-                          </m:sSubPr>
-                          <m:e>
-                            <m:r>
-                              <m:rPr>
-                                <m:sty m:val="p"/>
-                              </m:rPr>
-                              <a:rPr lang="en-US" sz="1600" b="0" i="0" smtClean="0">
-                                <a:latin typeface="Cambria Math" panose="02040503050406030204" pitchFamily="18" charset="0"/>
-                              </a:rPr>
-                              <m:t>log</m:t>
-                            </m:r>
-                          </m:e>
-                          <m:sub>
-                            <m:r>
-                              <a:rPr lang="en-US" sz="1600" b="0" i="1" smtClean="0">
-                                <a:latin typeface="Cambria Math" panose="02040503050406030204" pitchFamily="18" charset="0"/>
-                              </a:rPr>
-                              <m:t>2</m:t>
-                            </m:r>
-                          </m:sub>
-                        </m:sSub>
-                      </m:fName>
-                      <m:e>
-                        <m:r>
-                          <a:rPr lang="en-US" sz="1600" b="0" i="1" smtClean="0">
-                            <a:latin typeface="Cambria Math" panose="02040503050406030204" pitchFamily="18" charset="0"/>
-                          </a:rPr>
-                          <m:t>(</m:t>
-                        </m:r>
-                        <m:r>
-                          <a:rPr lang="en-US" sz="1600" b="0" i="1" smtClean="0">
-                            <a:latin typeface="Cambria Math" panose="02040503050406030204" pitchFamily="18" charset="0"/>
-                          </a:rPr>
-                          <m:t>𝑁</m:t>
-                        </m:r>
-                        <m:r>
-                          <a:rPr lang="en-US" sz="1600" b="0" i="1" smtClean="0">
-                            <a:latin typeface="Cambria Math" panose="02040503050406030204" pitchFamily="18" charset="0"/>
-                          </a:rPr>
-                          <m:t>)</m:t>
-                        </m:r>
-                      </m:e>
-                    </m:func>
-                    <m:r>
-                      <a:rPr lang="en-US" sz="1600" b="0" i="1" smtClean="0">
-                        <a:latin typeface="Cambria Math" panose="02040503050406030204" pitchFamily="18" charset="0"/>
-                      </a:rPr>
-                      <m:t> </m:t>
-                    </m:r>
-                  </m:oMath>
-                </a14:m>
-                <a:r>
-                  <a:rPr lang="en-US" sz="1600" dirty="0"/>
-                  <a:t>bits</a:t>
-                </a:r>
-              </a:p>
-            </p:txBody>
-          </p:sp>
-        </mc:Choice>
-        <mc:Fallback xmlns="">
-          <p:sp>
-            <p:nvSpPr>
-              <p:cNvPr id="8" name="TextBox 7">
-                <a:extLst>
-                  <a:ext uri="{FF2B5EF4-FFF2-40B4-BE49-F238E27FC236}">
-                    <a16:creationId xmlns:a16="http://schemas.microsoft.com/office/drawing/2014/main" id="{D813B71A-C912-EBEC-25EA-1B920697ED87}"/>
-                  </a:ext>
-                </a:extLst>
-              </p:cNvPr>
-              <p:cNvSpPr txBox="1">
-                <a:spLocks noRot="1" noChangeAspect="1" noMove="1" noResize="1" noEditPoints="1" noAdjustHandles="1" noChangeArrowheads="1" noChangeShapeType="1" noTextEdit="1"/>
-              </p:cNvSpPr>
-              <p:nvPr/>
-            </p:nvSpPr>
-            <p:spPr>
-              <a:xfrm>
-                <a:off x="324438" y="2579880"/>
-                <a:ext cx="1334533" cy="584775"/>
-              </a:xfrm>
-              <a:prstGeom prst="rect">
-                <a:avLst/>
-              </a:prstGeom>
-              <a:blipFill>
-                <a:blip r:embed="rId3"/>
-                <a:stretch>
-                  <a:fillRect l="-2283" t="-3125" r="-1370" b="-12500"/>
-                </a:stretch>
-              </a:blipFill>
-            </p:spPr>
-            <p:txBody>
-              <a:bodyPr/>
-              <a:lstStyle/>
-              <a:p>
-                <a:r>
-                  <a:rPr lang="en-US">
-                    <a:noFill/>
-                  </a:rPr>
-                  <a:t> </a:t>
-                </a:r>
-              </a:p>
-            </p:txBody>
-          </p:sp>
-        </mc:Fallback>
-      </mc:AlternateContent>
-      <p:cxnSp>
-        <p:nvCxnSpPr>
-          <p:cNvPr id="10" name="Straight Connector 9">
-            <a:extLst>
-              <a:ext uri="{FF2B5EF4-FFF2-40B4-BE49-F238E27FC236}">
-                <a16:creationId xmlns:a16="http://schemas.microsoft.com/office/drawing/2014/main" id="{19869FFE-A147-C690-6340-2F5C376B7EA2}"/>
-              </a:ext>
-            </a:extLst>
-          </p:cNvPr>
-          <p:cNvCxnSpPr>
-            <a:cxnSpLocks/>
-          </p:cNvCxnSpPr>
-          <p:nvPr/>
-        </p:nvCxnSpPr>
-        <p:spPr>
-          <a:xfrm flipH="1">
-            <a:off x="3143624" y="2476733"/>
-            <a:ext cx="30388" cy="2334152"/>
-          </a:xfrm>
-          <a:prstGeom prst="line">
-            <a:avLst/>
-          </a:prstGeom>
-          <a:ln>
-            <a:solidFill>
-              <a:schemeClr val="accent5">
-                <a:lumMod val="50000"/>
-              </a:schemeClr>
-            </a:solidFill>
-          </a:ln>
-        </p:spPr>
-        <p:style>
-          <a:lnRef idx="1">
-            <a:schemeClr val="accent1"/>
-          </a:lnRef>
-          <a:fillRef idx="0">
-            <a:schemeClr val="accent1"/>
-          </a:fillRef>
-          <a:effectRef idx="0">
-            <a:schemeClr val="accent1"/>
-          </a:effectRef>
-          <a:fontRef idx="minor">
-            <a:schemeClr val="tx1"/>
-          </a:fontRef>
-        </p:style>
-      </p:cxnSp>
-      <p:cxnSp>
-        <p:nvCxnSpPr>
-          <p:cNvPr id="23" name="Straight Arrow Connector 22">
-            <a:extLst>
-              <a:ext uri="{FF2B5EF4-FFF2-40B4-BE49-F238E27FC236}">
-                <a16:creationId xmlns:a16="http://schemas.microsoft.com/office/drawing/2014/main" id="{F454F599-A6A0-983D-571E-C1AE74BDCB60}"/>
-              </a:ext>
-            </a:extLst>
-          </p:cNvPr>
-          <p:cNvCxnSpPr/>
-          <p:nvPr/>
-        </p:nvCxnSpPr>
-        <p:spPr>
-          <a:xfrm>
-            <a:off x="947217" y="3196939"/>
-            <a:ext cx="738563" cy="0"/>
-          </a:xfrm>
-          <a:prstGeom prst="straightConnector1">
-            <a:avLst/>
-          </a:prstGeom>
-          <a:ln>
-            <a:solidFill>
-              <a:schemeClr val="accent5">
-                <a:lumMod val="50000"/>
-              </a:schemeClr>
-            </a:solidFill>
-            <a:tailEnd type="triangle"/>
-          </a:ln>
-        </p:spPr>
-        <p:style>
-          <a:lnRef idx="1">
-            <a:schemeClr val="accent1"/>
-          </a:lnRef>
-          <a:fillRef idx="0">
-            <a:schemeClr val="accent1"/>
-          </a:fillRef>
-          <a:effectRef idx="0">
-            <a:schemeClr val="accent1"/>
-          </a:effectRef>
-          <a:fontRef idx="minor">
-            <a:schemeClr val="tx1"/>
-          </a:fontRef>
-        </p:style>
-      </p:cxnSp>
-      <mc:AlternateContent xmlns:mc="http://schemas.openxmlformats.org/markup-compatibility/2006" xmlns:a14="http://schemas.microsoft.com/office/drawing/2010/main">
-        <mc:Choice Requires="a14">
-          <p:sp>
-            <p:nvSpPr>
-              <p:cNvPr id="24" name="TextBox 23">
-                <a:extLst>
-                  <a:ext uri="{FF2B5EF4-FFF2-40B4-BE49-F238E27FC236}">
-                    <a16:creationId xmlns:a16="http://schemas.microsoft.com/office/drawing/2014/main" id="{ED36180D-2EDA-541A-94AF-D513A7E12E55}"/>
-                  </a:ext>
-                </a:extLst>
-              </p:cNvPr>
-              <p:cNvSpPr txBox="1"/>
-              <p:nvPr/>
-            </p:nvSpPr>
-            <p:spPr>
-              <a:xfrm>
-                <a:off x="1643390" y="3747300"/>
-                <a:ext cx="1350050" cy="1077218"/>
-              </a:xfrm>
-              <a:prstGeom prst="rect">
-                <a:avLst/>
-              </a:prstGeom>
-              <a:noFill/>
-            </p:spPr>
-            <p:txBody>
-              <a:bodyPr wrap="none" rtlCol="0">
-                <a:spAutoFit/>
-              </a:bodyPr>
-              <a:lstStyle/>
-              <a:p>
-                <a:r>
-                  <a:rPr lang="en-US" sz="1600" dirty="0">
-                    <a:solidFill>
-                      <a:schemeClr val="accent6">
-                        <a:lumMod val="75000"/>
-                      </a:schemeClr>
-                    </a:solidFill>
-                  </a:rPr>
-                  <a:t>Address </a:t>
-                </a:r>
-                <a:br>
-                  <a:rPr lang="en-US" sz="1600" dirty="0">
-                    <a:solidFill>
-                      <a:schemeClr val="accent6">
-                        <a:lumMod val="75000"/>
-                      </a:schemeClr>
-                    </a:solidFill>
-                  </a:rPr>
-                </a:br>
-                <a:r>
-                  <a:rPr lang="en-US" sz="1600" dirty="0">
-                    <a:solidFill>
-                      <a:schemeClr val="accent6">
-                        <a:lumMod val="75000"/>
-                      </a:schemeClr>
-                    </a:solidFill>
-                  </a:rPr>
-                  <a:t>decoder</a:t>
-                </a:r>
-                <a:br>
-                  <a:rPr lang="en-US" sz="1600" dirty="0"/>
-                </a:br>
-                <a:r>
-                  <a:rPr lang="en-US" sz="1600" dirty="0"/>
-                  <a:t>Selects one of</a:t>
-                </a:r>
-              </a:p>
-              <a:p>
-                <a14:m>
-                  <m:oMath xmlns:m="http://schemas.openxmlformats.org/officeDocument/2006/math">
-                    <m:r>
-                      <a:rPr lang="en-US" sz="1600" b="0" i="1" smtClean="0">
-                        <a:latin typeface="Cambria Math" panose="02040503050406030204" pitchFamily="18" charset="0"/>
-                      </a:rPr>
-                      <m:t>𝑁</m:t>
-                    </m:r>
-                  </m:oMath>
-                </a14:m>
-                <a:r>
-                  <a:rPr lang="en-US" sz="1600" dirty="0"/>
-                  <a:t> </a:t>
-                </a:r>
-                <a:r>
-                  <a:rPr lang="en-US" sz="1600" dirty="0">
-                    <a:solidFill>
-                      <a:schemeClr val="accent6">
-                        <a:lumMod val="75000"/>
-                      </a:schemeClr>
-                    </a:solidFill>
-                  </a:rPr>
-                  <a:t>wordlines</a:t>
-                </a:r>
-              </a:p>
-            </p:txBody>
-          </p:sp>
-        </mc:Choice>
-        <mc:Fallback xmlns="">
-          <p:sp>
-            <p:nvSpPr>
-              <p:cNvPr id="24" name="TextBox 23">
-                <a:extLst>
-                  <a:ext uri="{FF2B5EF4-FFF2-40B4-BE49-F238E27FC236}">
-                    <a16:creationId xmlns:a16="http://schemas.microsoft.com/office/drawing/2014/main" id="{ED36180D-2EDA-541A-94AF-D513A7E12E55}"/>
-                  </a:ext>
-                </a:extLst>
-              </p:cNvPr>
-              <p:cNvSpPr txBox="1">
-                <a:spLocks noRot="1" noChangeAspect="1" noMove="1" noResize="1" noEditPoints="1" noAdjustHandles="1" noChangeArrowheads="1" noChangeShapeType="1" noTextEdit="1"/>
-              </p:cNvSpPr>
-              <p:nvPr/>
-            </p:nvSpPr>
-            <p:spPr>
-              <a:xfrm>
-                <a:off x="1643390" y="3747300"/>
-                <a:ext cx="1350050" cy="1077218"/>
-              </a:xfrm>
-              <a:prstGeom prst="rect">
-                <a:avLst/>
-              </a:prstGeom>
-              <a:blipFill>
-                <a:blip r:embed="rId4"/>
-                <a:stretch>
-                  <a:fillRect l="-2715" t="-1705" r="-905" b="-6818"/>
-                </a:stretch>
-              </a:blipFill>
-            </p:spPr>
-            <p:txBody>
-              <a:bodyPr/>
-              <a:lstStyle/>
-              <a:p>
-                <a:r>
-                  <a:rPr lang="en-US">
-                    <a:noFill/>
-                  </a:rPr>
-                  <a:t> </a:t>
-                </a:r>
-              </a:p>
-            </p:txBody>
-          </p:sp>
-        </mc:Fallback>
-      </mc:AlternateContent>
-      <mc:AlternateContent xmlns:mc="http://schemas.openxmlformats.org/markup-compatibility/2006" xmlns:a14="http://schemas.microsoft.com/office/drawing/2010/main">
-        <mc:Choice Requires="a14">
-          <p:sp>
-            <p:nvSpPr>
-              <p:cNvPr id="25" name="TextBox 24">
-                <a:extLst>
-                  <a:ext uri="{FF2B5EF4-FFF2-40B4-BE49-F238E27FC236}">
-                    <a16:creationId xmlns:a16="http://schemas.microsoft.com/office/drawing/2014/main" id="{0527EA86-35F3-424D-82DB-21531A48F3B9}"/>
-                  </a:ext>
-                </a:extLst>
-              </p:cNvPr>
-              <p:cNvSpPr txBox="1"/>
-              <p:nvPr/>
-            </p:nvSpPr>
-            <p:spPr>
-              <a:xfrm>
-                <a:off x="2197380" y="1990396"/>
-                <a:ext cx="1201226" cy="338554"/>
-              </a:xfrm>
-              <a:prstGeom prst="rect">
-                <a:avLst/>
-              </a:prstGeom>
-              <a:noFill/>
-            </p:spPr>
-            <p:txBody>
-              <a:bodyPr wrap="none" rtlCol="0">
-                <a:spAutoFit/>
-              </a:bodyPr>
-              <a:lstStyle/>
-              <a:p>
-                <a14:m>
-                  <m:oMath xmlns:m="http://schemas.openxmlformats.org/officeDocument/2006/math">
-                    <m:r>
-                      <a:rPr lang="en-US" sz="1600" b="0" i="1" smtClean="0">
-                        <a:latin typeface="Cambria Math" panose="02040503050406030204" pitchFamily="18" charset="0"/>
-                      </a:rPr>
-                      <m:t>𝑁</m:t>
-                    </m:r>
-                  </m:oMath>
-                </a14:m>
-                <a:r>
-                  <a:rPr lang="en-US" sz="1600" dirty="0"/>
-                  <a:t> </a:t>
-                </a:r>
-                <a:r>
-                  <a:rPr lang="en-US" sz="1600" dirty="0">
-                    <a:solidFill>
-                      <a:schemeClr val="accent6">
-                        <a:lumMod val="75000"/>
-                      </a:schemeClr>
-                    </a:solidFill>
-                  </a:rPr>
-                  <a:t>wordlines</a:t>
-                </a:r>
-              </a:p>
-            </p:txBody>
-          </p:sp>
-        </mc:Choice>
-        <mc:Fallback xmlns="">
-          <p:sp>
-            <p:nvSpPr>
-              <p:cNvPr id="25" name="TextBox 24">
-                <a:extLst>
-                  <a:ext uri="{FF2B5EF4-FFF2-40B4-BE49-F238E27FC236}">
-                    <a16:creationId xmlns:a16="http://schemas.microsoft.com/office/drawing/2014/main" id="{0527EA86-35F3-424D-82DB-21531A48F3B9}"/>
-                  </a:ext>
-                </a:extLst>
-              </p:cNvPr>
-              <p:cNvSpPr txBox="1">
-                <a:spLocks noRot="1" noChangeAspect="1" noMove="1" noResize="1" noEditPoints="1" noAdjustHandles="1" noChangeArrowheads="1" noChangeShapeType="1" noTextEdit="1"/>
-              </p:cNvSpPr>
-              <p:nvPr/>
-            </p:nvSpPr>
-            <p:spPr>
-              <a:xfrm>
-                <a:off x="2197380" y="1990396"/>
-                <a:ext cx="1201226" cy="338554"/>
-              </a:xfrm>
-              <a:prstGeom prst="rect">
-                <a:avLst/>
-              </a:prstGeom>
-              <a:blipFill>
-                <a:blip r:embed="rId5"/>
-                <a:stretch>
-                  <a:fillRect t="-5455" r="-1515" b="-23636"/>
-                </a:stretch>
-              </a:blipFill>
-            </p:spPr>
-            <p:txBody>
-              <a:bodyPr/>
-              <a:lstStyle/>
-              <a:p>
-                <a:r>
-                  <a:rPr lang="en-US">
-                    <a:noFill/>
-                  </a:rPr>
-                  <a:t> </a:t>
-                </a:r>
-              </a:p>
-            </p:txBody>
-          </p:sp>
-        </mc:Fallback>
-      </mc:AlternateContent>
-      <mc:AlternateContent xmlns:mc="http://schemas.openxmlformats.org/markup-compatibility/2006" xmlns:a14="http://schemas.microsoft.com/office/drawing/2010/main">
-        <mc:Choice Requires="a14">
-          <p:sp>
-            <p:nvSpPr>
-              <p:cNvPr id="33" name="TextBox 32">
-                <a:extLst>
-                  <a:ext uri="{FF2B5EF4-FFF2-40B4-BE49-F238E27FC236}">
-                    <a16:creationId xmlns:a16="http://schemas.microsoft.com/office/drawing/2014/main" id="{0F464507-89E5-BDF2-C5B1-B406436F7580}"/>
-                  </a:ext>
-                </a:extLst>
-              </p:cNvPr>
-              <p:cNvSpPr txBox="1"/>
-              <p:nvPr/>
-            </p:nvSpPr>
-            <p:spPr>
-              <a:xfrm>
-                <a:off x="4190176" y="3473352"/>
-                <a:ext cx="349775" cy="461665"/>
-              </a:xfrm>
-              <a:prstGeom prst="rect">
-                <a:avLst/>
-              </a:prstGeom>
-              <a:noFill/>
-            </p:spPr>
-            <p:txBody>
-              <a:bodyPr wrap="none" rtlCol="0">
-                <a:spAutoFit/>
-              </a:bodyPr>
-              <a:lstStyle/>
-              <a:p>
-                <a:pPr/>
-                <a14:m>
-                  <m:oMathPara xmlns:m="http://schemas.openxmlformats.org/officeDocument/2006/math">
-                    <m:oMathParaPr>
-                      <m:jc m:val="centerGroup"/>
-                    </m:oMathParaPr>
-                    <m:oMath xmlns:m="http://schemas.openxmlformats.org/officeDocument/2006/math">
-                      <m:r>
-                        <a:rPr lang="en-US" sz="2400" b="0" i="1" smtClean="0">
-                          <a:solidFill>
-                            <a:schemeClr val="accent1">
-                              <a:lumMod val="60000"/>
-                              <a:lumOff val="40000"/>
-                            </a:schemeClr>
-                          </a:solidFill>
-                          <a:latin typeface="Cambria Math" panose="02040503050406030204" pitchFamily="18" charset="0"/>
-                        </a:rPr>
-                        <m:t>⋮</m:t>
-                      </m:r>
-                    </m:oMath>
-                  </m:oMathPara>
-                </a14:m>
-                <a:endParaRPr lang="en-US" sz="2400" dirty="0">
-                  <a:solidFill>
-                    <a:schemeClr val="accent1">
-                      <a:lumMod val="60000"/>
-                      <a:lumOff val="40000"/>
-                    </a:schemeClr>
-                  </a:solidFill>
-                </a:endParaRPr>
-              </a:p>
-            </p:txBody>
-          </p:sp>
-        </mc:Choice>
-        <mc:Fallback xmlns="">
-          <p:sp>
-            <p:nvSpPr>
-              <p:cNvPr id="33" name="TextBox 32">
-                <a:extLst>
-                  <a:ext uri="{FF2B5EF4-FFF2-40B4-BE49-F238E27FC236}">
-                    <a16:creationId xmlns:a16="http://schemas.microsoft.com/office/drawing/2014/main" id="{0F464507-89E5-BDF2-C5B1-B406436F7580}"/>
-                  </a:ext>
-                </a:extLst>
-              </p:cNvPr>
-              <p:cNvSpPr txBox="1">
-                <a:spLocks noRot="1" noChangeAspect="1" noMove="1" noResize="1" noEditPoints="1" noAdjustHandles="1" noChangeArrowheads="1" noChangeShapeType="1" noTextEdit="1"/>
-              </p:cNvSpPr>
-              <p:nvPr/>
-            </p:nvSpPr>
-            <p:spPr>
-              <a:xfrm>
-                <a:off x="4190176" y="3473352"/>
-                <a:ext cx="349775" cy="461665"/>
-              </a:xfrm>
-              <a:prstGeom prst="rect">
-                <a:avLst/>
-              </a:prstGeom>
-              <a:blipFill>
-                <a:blip r:embed="rId6"/>
-                <a:stretch>
-                  <a:fillRect/>
-                </a:stretch>
-              </a:blipFill>
-            </p:spPr>
-            <p:txBody>
-              <a:bodyPr/>
-              <a:lstStyle/>
-              <a:p>
-                <a:r>
-                  <a:rPr lang="en-US">
-                    <a:noFill/>
-                  </a:rPr>
-                  <a:t> </a:t>
-                </a:r>
-              </a:p>
-            </p:txBody>
-          </p:sp>
-        </mc:Fallback>
-      </mc:AlternateContent>
-      <mc:AlternateContent xmlns:mc="http://schemas.openxmlformats.org/markup-compatibility/2006" xmlns:a14="http://schemas.microsoft.com/office/drawing/2010/main">
-        <mc:Choice Requires="a14">
-          <p:sp>
-            <p:nvSpPr>
-              <p:cNvPr id="34" name="TextBox 33">
-                <a:extLst>
-                  <a:ext uri="{FF2B5EF4-FFF2-40B4-BE49-F238E27FC236}">
-                    <a16:creationId xmlns:a16="http://schemas.microsoft.com/office/drawing/2014/main" id="{F1DBB8A8-5A6E-D7C3-0CF7-7F2498B56FE4}"/>
-                  </a:ext>
-                </a:extLst>
-              </p:cNvPr>
-              <p:cNvSpPr txBox="1"/>
-              <p:nvPr/>
-            </p:nvSpPr>
-            <p:spPr>
-              <a:xfrm>
-                <a:off x="3340700" y="3545028"/>
-                <a:ext cx="349775" cy="461665"/>
-              </a:xfrm>
-              <a:prstGeom prst="rect">
-                <a:avLst/>
-              </a:prstGeom>
-              <a:noFill/>
-            </p:spPr>
-            <p:txBody>
-              <a:bodyPr wrap="none" rtlCol="0">
-                <a:spAutoFit/>
-              </a:bodyPr>
-              <a:lstStyle/>
-              <a:p>
-                <a:pPr/>
-                <a14:m>
-                  <m:oMathPara xmlns:m="http://schemas.openxmlformats.org/officeDocument/2006/math">
-                    <m:oMathParaPr>
-                      <m:jc m:val="centerGroup"/>
-                    </m:oMathParaPr>
-                    <m:oMath xmlns:m="http://schemas.openxmlformats.org/officeDocument/2006/math">
-                      <m:r>
-                        <a:rPr lang="en-US" sz="2400" b="0" i="1" smtClean="0">
-                          <a:solidFill>
-                            <a:schemeClr val="accent1">
-                              <a:lumMod val="60000"/>
-                              <a:lumOff val="40000"/>
-                            </a:schemeClr>
-                          </a:solidFill>
-                          <a:latin typeface="Cambria Math" panose="02040503050406030204" pitchFamily="18" charset="0"/>
-                        </a:rPr>
-                        <m:t>⋮</m:t>
-                      </m:r>
-                    </m:oMath>
-                  </m:oMathPara>
-                </a14:m>
-                <a:endParaRPr lang="en-US" sz="2400" dirty="0">
-                  <a:solidFill>
-                    <a:schemeClr val="accent1">
-                      <a:lumMod val="60000"/>
-                      <a:lumOff val="40000"/>
-                    </a:schemeClr>
-                  </a:solidFill>
-                </a:endParaRPr>
-              </a:p>
-            </p:txBody>
-          </p:sp>
-        </mc:Choice>
-        <mc:Fallback xmlns="">
-          <p:sp>
-            <p:nvSpPr>
-              <p:cNvPr id="34" name="TextBox 33">
-                <a:extLst>
-                  <a:ext uri="{FF2B5EF4-FFF2-40B4-BE49-F238E27FC236}">
-                    <a16:creationId xmlns:a16="http://schemas.microsoft.com/office/drawing/2014/main" id="{F1DBB8A8-5A6E-D7C3-0CF7-7F2498B56FE4}"/>
-                  </a:ext>
-                </a:extLst>
-              </p:cNvPr>
-              <p:cNvSpPr txBox="1">
-                <a:spLocks noRot="1" noChangeAspect="1" noMove="1" noResize="1" noEditPoints="1" noAdjustHandles="1" noChangeArrowheads="1" noChangeShapeType="1" noTextEdit="1"/>
-              </p:cNvSpPr>
-              <p:nvPr/>
-            </p:nvSpPr>
-            <p:spPr>
-              <a:xfrm>
-                <a:off x="3340700" y="3545028"/>
-                <a:ext cx="349775" cy="461665"/>
-              </a:xfrm>
-              <a:prstGeom prst="rect">
-                <a:avLst/>
-              </a:prstGeom>
-              <a:blipFill>
-                <a:blip r:embed="rId7"/>
-                <a:stretch>
-                  <a:fillRect/>
-                </a:stretch>
-              </a:blipFill>
-            </p:spPr>
-            <p:txBody>
-              <a:bodyPr/>
-              <a:lstStyle/>
-              <a:p>
-                <a:r>
-                  <a:rPr lang="en-US">
-                    <a:noFill/>
-                  </a:rPr>
-                  <a:t> </a:t>
-                </a:r>
-              </a:p>
-            </p:txBody>
-          </p:sp>
-        </mc:Fallback>
-      </mc:AlternateContent>
       <p:grpSp>
         <p:nvGrpSpPr>
-          <p:cNvPr id="61" name="Group 60">
-            <a:extLst>
-              <a:ext uri="{FF2B5EF4-FFF2-40B4-BE49-F238E27FC236}">
-                <a16:creationId xmlns:a16="http://schemas.microsoft.com/office/drawing/2014/main" id="{EF733FA4-307B-C512-F380-F8D34A28BA50}"/>
+          <p:cNvPr id="9" name="Group 8">
+            <a:extLst>
+              <a:ext uri="{FF2B5EF4-FFF2-40B4-BE49-F238E27FC236}">
+                <a16:creationId xmlns:a16="http://schemas.microsoft.com/office/drawing/2014/main" id="{C8C29252-EDB7-C199-18FF-5CF93424698B}"/>
               </a:ext>
             </a:extLst>
           </p:cNvPr>
@@ -31012,18 +30083,441 @@
         </p:nvGrpSpPr>
         <p:grpSpPr>
           <a:xfrm>
-            <a:off x="3167386" y="2308781"/>
-            <a:ext cx="2397325" cy="296148"/>
-            <a:chOff x="3167386" y="2308781"/>
-            <a:chExt cx="2397325" cy="296148"/>
+            <a:off x="324438" y="1630137"/>
+            <a:ext cx="5693185" cy="3421538"/>
+            <a:chOff x="324438" y="1630137"/>
+            <a:chExt cx="5693185" cy="3421538"/>
           </a:xfrm>
         </p:grpSpPr>
+        <p:sp>
+          <p:nvSpPr>
+            <p:cNvPr id="80" name="Rectangle 79">
+              <a:extLst>
+                <a:ext uri="{FF2B5EF4-FFF2-40B4-BE49-F238E27FC236}">
+                  <a16:creationId xmlns:a16="http://schemas.microsoft.com/office/drawing/2014/main" id="{F6C25994-24DD-3620-4CAE-83A7CB132B95}"/>
+                </a:ext>
+              </a:extLst>
+            </p:cNvPr>
+            <p:cNvSpPr/>
+            <p:nvPr/>
+          </p:nvSpPr>
+          <p:spPr>
+            <a:xfrm>
+              <a:off x="3902065" y="2308781"/>
+              <a:ext cx="914317" cy="2640065"/>
+            </a:xfrm>
+            <a:prstGeom prst="rect">
+              <a:avLst/>
+            </a:prstGeom>
+            <a:solidFill>
+              <a:schemeClr val="accent1">
+                <a:lumMod val="20000"/>
+                <a:lumOff val="80000"/>
+              </a:schemeClr>
+            </a:solidFill>
+          </p:spPr>
+          <p:style>
+            <a:lnRef idx="2">
+              <a:schemeClr val="accent1">
+                <a:shade val="15000"/>
+              </a:schemeClr>
+            </a:lnRef>
+            <a:fillRef idx="1">
+              <a:schemeClr val="accent1"/>
+            </a:fillRef>
+            <a:effectRef idx="0">
+              <a:schemeClr val="accent1"/>
+            </a:effectRef>
+            <a:fontRef idx="minor">
+              <a:schemeClr val="lt1"/>
+            </a:fontRef>
+          </p:style>
+          <p:txBody>
+            <a:bodyPr rtlCol="0" anchor="ctr"/>
+            <a:lstStyle/>
+            <a:p>
+              <a:pPr algn="ctr"/>
+              <a:endParaRPr lang="en-US"/>
+            </a:p>
+          </p:txBody>
+        </p:sp>
+        <p:sp>
+          <p:nvSpPr>
+            <p:cNvPr id="5" name="Rectangle 4">
+              <a:extLst>
+                <a:ext uri="{FF2B5EF4-FFF2-40B4-BE49-F238E27FC236}">
+                  <a16:creationId xmlns:a16="http://schemas.microsoft.com/office/drawing/2014/main" id="{95A1FAD5-8D48-A21C-8DF4-36148C5B302E}"/>
+                </a:ext>
+              </a:extLst>
+            </p:cNvPr>
+            <p:cNvSpPr/>
+            <p:nvPr/>
+          </p:nvSpPr>
+          <p:spPr>
+            <a:xfrm>
+              <a:off x="1679370" y="2802744"/>
+              <a:ext cx="914400" cy="914400"/>
+            </a:xfrm>
+            <a:prstGeom prst="rect">
+              <a:avLst/>
+            </a:prstGeom>
+            <a:solidFill>
+              <a:schemeClr val="accent5">
+                <a:lumMod val="20000"/>
+                <a:lumOff val="80000"/>
+              </a:schemeClr>
+            </a:solidFill>
+            <a:ln>
+              <a:solidFill>
+                <a:schemeClr val="accent5">
+                  <a:lumMod val="75000"/>
+                </a:schemeClr>
+              </a:solidFill>
+            </a:ln>
+          </p:spPr>
+          <p:style>
+            <a:lnRef idx="2">
+              <a:schemeClr val="accent1">
+                <a:shade val="15000"/>
+              </a:schemeClr>
+            </a:lnRef>
+            <a:fillRef idx="1">
+              <a:schemeClr val="accent1"/>
+            </a:fillRef>
+            <a:effectRef idx="0">
+              <a:schemeClr val="accent1"/>
+            </a:effectRef>
+            <a:fontRef idx="minor">
+              <a:schemeClr val="lt1"/>
+            </a:fontRef>
+          </p:style>
+          <p:txBody>
+            <a:bodyPr rtlCol="0" anchor="ctr"/>
+            <a:lstStyle/>
+            <a:p>
+              <a:pPr algn="ctr"/>
+              <a:endParaRPr lang="en-US"/>
+            </a:p>
+          </p:txBody>
+        </p:sp>
+        <p:sp>
+          <p:nvSpPr>
+            <p:cNvPr id="6" name="Rectangle 5">
+              <a:extLst>
+                <a:ext uri="{FF2B5EF4-FFF2-40B4-BE49-F238E27FC236}">
+                  <a16:creationId xmlns:a16="http://schemas.microsoft.com/office/drawing/2014/main" id="{55B9A0E3-C243-06FE-69F7-6765D2A1CD2A}"/>
+                </a:ext>
+              </a:extLst>
+            </p:cNvPr>
+            <p:cNvSpPr/>
+            <p:nvPr/>
+          </p:nvSpPr>
+          <p:spPr>
+            <a:xfrm>
+              <a:off x="5565006" y="2169329"/>
+              <a:ext cx="310060" cy="2882346"/>
+            </a:xfrm>
+            <a:prstGeom prst="rect">
+              <a:avLst/>
+            </a:prstGeom>
+            <a:solidFill>
+              <a:srgbClr val="CCFF99"/>
+            </a:solidFill>
+            <a:ln>
+              <a:solidFill>
+                <a:schemeClr val="accent3">
+                  <a:lumMod val="75000"/>
+                </a:schemeClr>
+              </a:solidFill>
+            </a:ln>
+          </p:spPr>
+          <p:style>
+            <a:lnRef idx="2">
+              <a:schemeClr val="accent1">
+                <a:shade val="15000"/>
+              </a:schemeClr>
+            </a:lnRef>
+            <a:fillRef idx="1">
+              <a:schemeClr val="accent1"/>
+            </a:fillRef>
+            <a:effectRef idx="0">
+              <a:schemeClr val="accent1"/>
+            </a:effectRef>
+            <a:fontRef idx="minor">
+              <a:schemeClr val="lt1"/>
+            </a:fontRef>
+          </p:style>
+          <p:txBody>
+            <a:bodyPr rtlCol="0" anchor="ctr"/>
+            <a:lstStyle/>
+            <a:p>
+              <a:pPr algn="ctr"/>
+              <a:endParaRPr lang="en-US"/>
+            </a:p>
+          </p:txBody>
+        </p:sp>
+        <p:sp>
+          <p:nvSpPr>
+            <p:cNvPr id="7" name="Rectangle 6">
+              <a:extLst>
+                <a:ext uri="{FF2B5EF4-FFF2-40B4-BE49-F238E27FC236}">
+                  <a16:creationId xmlns:a16="http://schemas.microsoft.com/office/drawing/2014/main" id="{89E19483-793F-2739-2D1F-E802903699E3}"/>
+                </a:ext>
+              </a:extLst>
+            </p:cNvPr>
+            <p:cNvSpPr/>
+            <p:nvPr/>
+          </p:nvSpPr>
+          <p:spPr>
+            <a:xfrm>
+              <a:off x="3911830" y="2899598"/>
+              <a:ext cx="914317" cy="304811"/>
+            </a:xfrm>
+            <a:prstGeom prst="rect">
+              <a:avLst/>
+            </a:prstGeom>
+          </p:spPr>
+          <p:style>
+            <a:lnRef idx="2">
+              <a:schemeClr val="accent1">
+                <a:shade val="15000"/>
+              </a:schemeClr>
+            </a:lnRef>
+            <a:fillRef idx="1">
+              <a:schemeClr val="accent1"/>
+            </a:fillRef>
+            <a:effectRef idx="0">
+              <a:schemeClr val="accent1"/>
+            </a:effectRef>
+            <a:fontRef idx="minor">
+              <a:schemeClr val="lt1"/>
+            </a:fontRef>
+          </p:style>
+          <p:txBody>
+            <a:bodyPr rtlCol="0" anchor="ctr"/>
+            <a:lstStyle/>
+            <a:p>
+              <a:pPr algn="ctr"/>
+              <a:endParaRPr lang="en-US"/>
+            </a:p>
+          </p:txBody>
+        </p:sp>
+        <mc:AlternateContent xmlns:mc="http://schemas.openxmlformats.org/markup-compatibility/2006">
+          <mc:Choice xmlns:a14="http://schemas.microsoft.com/office/drawing/2010/main" Requires="a14">
+            <p:sp>
+              <p:nvSpPr>
+                <p:cNvPr id="8" name="TextBox 7">
+                  <a:extLst>
+                    <a:ext uri="{FF2B5EF4-FFF2-40B4-BE49-F238E27FC236}">
+                      <a16:creationId xmlns:a16="http://schemas.microsoft.com/office/drawing/2014/main" id="{D813B71A-C912-EBEC-25EA-1B920697ED87}"/>
+                    </a:ext>
+                  </a:extLst>
+                </p:cNvPr>
+                <p:cNvSpPr txBox="1"/>
+                <p:nvPr/>
+              </p:nvSpPr>
+              <p:spPr>
+                <a:xfrm>
+                  <a:off x="324438" y="2579880"/>
+                  <a:ext cx="1334533" cy="584775"/>
+                </a:xfrm>
+                <a:prstGeom prst="rect">
+                  <a:avLst/>
+                </a:prstGeom>
+                <a:noFill/>
+              </p:spPr>
+              <p:txBody>
+                <a:bodyPr wrap="none" rtlCol="0">
+                  <a:spAutoFit/>
+                </a:bodyPr>
+                <a:lstStyle/>
+                <a:p>
+                  <a:r>
+                    <a:rPr lang="en-US" sz="1600" dirty="0">
+                      <a:solidFill>
+                        <a:schemeClr val="accent6">
+                          <a:lumMod val="75000"/>
+                        </a:schemeClr>
+                      </a:solidFill>
+                    </a:rPr>
+                    <a:t>Address input</a:t>
+                  </a:r>
+                  <a:br>
+                    <a:rPr lang="en-US" sz="1600" dirty="0"/>
+                  </a:br>
+                  <a14:m>
+                    <m:oMath xmlns:m="http://schemas.openxmlformats.org/officeDocument/2006/math">
+                      <m:func>
+                        <m:funcPr>
+                          <m:ctrlPr>
+                            <a:rPr lang="en-US" sz="1600" b="0" i="1" smtClean="0">
+                              <a:latin typeface="Cambria Math" panose="02040503050406030204" pitchFamily="18" charset="0"/>
+                            </a:rPr>
+                          </m:ctrlPr>
+                        </m:funcPr>
+                        <m:fName>
+                          <m:sSub>
+                            <m:sSubPr>
+                              <m:ctrlPr>
+                                <a:rPr lang="en-US" sz="1600" b="0" i="1" smtClean="0">
+                                  <a:latin typeface="Cambria Math" panose="02040503050406030204" pitchFamily="18" charset="0"/>
+                                </a:rPr>
+                              </m:ctrlPr>
+                            </m:sSubPr>
+                            <m:e>
+                              <m:r>
+                                <m:rPr>
+                                  <m:sty m:val="p"/>
+                                </m:rPr>
+                                <a:rPr lang="en-US" sz="1600" b="0" i="0" smtClean="0">
+                                  <a:latin typeface="Cambria Math" panose="02040503050406030204" pitchFamily="18" charset="0"/>
+                                </a:rPr>
+                                <m:t>log</m:t>
+                              </m:r>
+                            </m:e>
+                            <m:sub>
+                              <m:r>
+                                <a:rPr lang="en-US" sz="1600" b="0" i="1" smtClean="0">
+                                  <a:latin typeface="Cambria Math" panose="02040503050406030204" pitchFamily="18" charset="0"/>
+                                </a:rPr>
+                                <m:t>2</m:t>
+                              </m:r>
+                            </m:sub>
+                          </m:sSub>
+                        </m:fName>
+                        <m:e>
+                          <m:r>
+                            <a:rPr lang="en-US" sz="1600" b="0" i="1" smtClean="0">
+                              <a:latin typeface="Cambria Math" panose="02040503050406030204" pitchFamily="18" charset="0"/>
+                            </a:rPr>
+                            <m:t>(</m:t>
+                          </m:r>
+                          <m:r>
+                            <a:rPr lang="en-US" sz="1600" b="0" i="1" smtClean="0">
+                              <a:latin typeface="Cambria Math" panose="02040503050406030204" pitchFamily="18" charset="0"/>
+                            </a:rPr>
+                            <m:t>𝑁</m:t>
+                          </m:r>
+                          <m:r>
+                            <a:rPr lang="en-US" sz="1600" b="0" i="1" smtClean="0">
+                              <a:latin typeface="Cambria Math" panose="02040503050406030204" pitchFamily="18" charset="0"/>
+                            </a:rPr>
+                            <m:t>)</m:t>
+                          </m:r>
+                        </m:e>
+                      </m:func>
+                      <m:r>
+                        <a:rPr lang="en-US" sz="1600" b="0" i="1" smtClean="0">
+                          <a:latin typeface="Cambria Math" panose="02040503050406030204" pitchFamily="18" charset="0"/>
+                        </a:rPr>
+                        <m:t> </m:t>
+                      </m:r>
+                    </m:oMath>
+                  </a14:m>
+                  <a:r>
+                    <a:rPr lang="en-US" sz="1600" dirty="0"/>
+                    <a:t>bits</a:t>
+                  </a:r>
+                </a:p>
+              </p:txBody>
+            </p:sp>
+          </mc:Choice>
+          <mc:Fallback>
+            <p:sp>
+              <p:nvSpPr>
+                <p:cNvPr id="8" name="TextBox 7">
+                  <a:extLst>
+                    <a:ext uri="{FF2B5EF4-FFF2-40B4-BE49-F238E27FC236}">
+                      <a16:creationId xmlns:a16="http://schemas.microsoft.com/office/drawing/2014/main" id="{D813B71A-C912-EBEC-25EA-1B920697ED87}"/>
+                    </a:ext>
+                  </a:extLst>
+                </p:cNvPr>
+                <p:cNvSpPr txBox="1">
+                  <a:spLocks noRot="1" noChangeAspect="1" noMove="1" noResize="1" noEditPoints="1" noAdjustHandles="1" noChangeArrowheads="1" noChangeShapeType="1" noTextEdit="1"/>
+                </p:cNvSpPr>
+                <p:nvPr/>
+              </p:nvSpPr>
+              <p:spPr>
+                <a:xfrm>
+                  <a:off x="324438" y="2579880"/>
+                  <a:ext cx="1334533" cy="584775"/>
+                </a:xfrm>
+                <a:prstGeom prst="rect">
+                  <a:avLst/>
+                </a:prstGeom>
+                <a:blipFill>
+                  <a:blip r:embed="rId3"/>
+                  <a:stretch>
+                    <a:fillRect l="-2283" t="-3125" r="-1370" b="-12500"/>
+                  </a:stretch>
+                </a:blipFill>
+              </p:spPr>
+              <p:txBody>
+                <a:bodyPr/>
+                <a:lstStyle/>
+                <a:p>
+                  <a:r>
+                    <a:rPr lang="en-US">
+                      <a:noFill/>
+                    </a:rPr>
+                    <a:t> </a:t>
+                  </a:r>
+                </a:p>
+              </p:txBody>
+            </p:sp>
+          </mc:Fallback>
+        </mc:AlternateContent>
         <p:cxnSp>
           <p:nvCxnSpPr>
-            <p:cNvPr id="13" name="Straight Arrow Connector 12">
+            <p:cNvPr id="10" name="Straight Connector 9">
               <a:extLst>
                 <a:ext uri="{FF2B5EF4-FFF2-40B4-BE49-F238E27FC236}">
-                  <a16:creationId xmlns:a16="http://schemas.microsoft.com/office/drawing/2014/main" id="{9A6A75BD-5C70-CFFA-DD52-79FD0A8AD965}"/>
+                  <a16:creationId xmlns:a16="http://schemas.microsoft.com/office/drawing/2014/main" id="{19869FFE-A147-C690-6340-2F5C376B7EA2}"/>
+                </a:ext>
+              </a:extLst>
+            </p:cNvPr>
+            <p:cNvCxnSpPr>
+              <a:cxnSpLocks/>
+            </p:cNvCxnSpPr>
+            <p:nvPr/>
+          </p:nvCxnSpPr>
+          <p:spPr>
+            <a:xfrm flipH="1">
+              <a:off x="3143624" y="2476733"/>
+              <a:ext cx="30388" cy="2334152"/>
+            </a:xfrm>
+            <a:prstGeom prst="line">
+              <a:avLst/>
+            </a:prstGeom>
+            <a:ln>
+              <a:solidFill>
+                <a:schemeClr val="accent5">
+                  <a:lumMod val="50000"/>
+                </a:schemeClr>
+              </a:solidFill>
+            </a:ln>
+          </p:spPr>
+          <p:style>
+            <a:lnRef idx="1">
+              <a:schemeClr val="accent1"/>
+            </a:lnRef>
+            <a:fillRef idx="0">
+              <a:schemeClr val="accent1"/>
+            </a:fillRef>
+            <a:effectRef idx="0">
+              <a:schemeClr val="accent1"/>
+            </a:effectRef>
+            <a:fontRef idx="minor">
+              <a:schemeClr val="tx1"/>
+            </a:fontRef>
+          </p:style>
+        </p:cxnSp>
+        <p:cxnSp>
+          <p:nvCxnSpPr>
+            <p:cNvPr id="23" name="Straight Arrow Connector 22">
+              <a:extLst>
+                <a:ext uri="{FF2B5EF4-FFF2-40B4-BE49-F238E27FC236}">
+                  <a16:creationId xmlns:a16="http://schemas.microsoft.com/office/drawing/2014/main" id="{F454F599-A6A0-983D-571E-C1AE74BDCB60}"/>
                 </a:ext>
               </a:extLst>
             </p:cNvPr>
@@ -31032,7 +30526,7 @@
           </p:nvCxnSpPr>
           <p:spPr>
             <a:xfrm>
-              <a:off x="3167386" y="2472526"/>
+              <a:off x="947217" y="3196939"/>
               <a:ext cx="738563" cy="0"/>
             </a:xfrm>
             <a:prstGeom prst="straightConnector1">
@@ -31040,8 +30534,710 @@
             </a:prstGeom>
             <a:ln>
               <a:solidFill>
-                <a:schemeClr val="accent6">
-                  <a:lumMod val="75000"/>
+                <a:schemeClr val="accent5">
+                  <a:lumMod val="50000"/>
+                </a:schemeClr>
+              </a:solidFill>
+              <a:tailEnd type="triangle"/>
+            </a:ln>
+          </p:spPr>
+          <p:style>
+            <a:lnRef idx="1">
+              <a:schemeClr val="accent1"/>
+            </a:lnRef>
+            <a:fillRef idx="0">
+              <a:schemeClr val="accent1"/>
+            </a:fillRef>
+            <a:effectRef idx="0">
+              <a:schemeClr val="accent1"/>
+            </a:effectRef>
+            <a:fontRef idx="minor">
+              <a:schemeClr val="tx1"/>
+            </a:fontRef>
+          </p:style>
+        </p:cxnSp>
+        <mc:AlternateContent xmlns:mc="http://schemas.openxmlformats.org/markup-compatibility/2006">
+          <mc:Choice xmlns:a14="http://schemas.microsoft.com/office/drawing/2010/main" Requires="a14">
+            <p:sp>
+              <p:nvSpPr>
+                <p:cNvPr id="24" name="TextBox 23">
+                  <a:extLst>
+                    <a:ext uri="{FF2B5EF4-FFF2-40B4-BE49-F238E27FC236}">
+                      <a16:creationId xmlns:a16="http://schemas.microsoft.com/office/drawing/2014/main" id="{ED36180D-2EDA-541A-94AF-D513A7E12E55}"/>
+                    </a:ext>
+                  </a:extLst>
+                </p:cNvPr>
+                <p:cNvSpPr txBox="1"/>
+                <p:nvPr/>
+              </p:nvSpPr>
+              <p:spPr>
+                <a:xfrm>
+                  <a:off x="1643390" y="3747300"/>
+                  <a:ext cx="1350050" cy="1077218"/>
+                </a:xfrm>
+                <a:prstGeom prst="rect">
+                  <a:avLst/>
+                </a:prstGeom>
+                <a:noFill/>
+              </p:spPr>
+              <p:txBody>
+                <a:bodyPr wrap="none" rtlCol="0">
+                  <a:spAutoFit/>
+                </a:bodyPr>
+                <a:lstStyle/>
+                <a:p>
+                  <a:r>
+                    <a:rPr lang="en-US" sz="1600" dirty="0">
+                      <a:solidFill>
+                        <a:schemeClr val="accent6">
+                          <a:lumMod val="75000"/>
+                        </a:schemeClr>
+                      </a:solidFill>
+                    </a:rPr>
+                    <a:t>Address </a:t>
+                  </a:r>
+                  <a:br>
+                    <a:rPr lang="en-US" sz="1600" dirty="0">
+                      <a:solidFill>
+                        <a:schemeClr val="accent6">
+                          <a:lumMod val="75000"/>
+                        </a:schemeClr>
+                      </a:solidFill>
+                    </a:rPr>
+                  </a:br>
+                  <a:r>
+                    <a:rPr lang="en-US" sz="1600" dirty="0">
+                      <a:solidFill>
+                        <a:schemeClr val="accent6">
+                          <a:lumMod val="75000"/>
+                        </a:schemeClr>
+                      </a:solidFill>
+                    </a:rPr>
+                    <a:t>decoder</a:t>
+                  </a:r>
+                  <a:br>
+                    <a:rPr lang="en-US" sz="1600" dirty="0"/>
+                  </a:br>
+                  <a:r>
+                    <a:rPr lang="en-US" sz="1600" dirty="0"/>
+                    <a:t>Selects one of</a:t>
+                  </a:r>
+                </a:p>
+                <a:p>
+                  <a14:m>
+                    <m:oMath xmlns:m="http://schemas.openxmlformats.org/officeDocument/2006/math">
+                      <m:r>
+                        <a:rPr lang="en-US" sz="1600" b="0" i="1" smtClean="0">
+                          <a:latin typeface="Cambria Math" panose="02040503050406030204" pitchFamily="18" charset="0"/>
+                        </a:rPr>
+                        <m:t>𝑁</m:t>
+                      </m:r>
+                    </m:oMath>
+                  </a14:m>
+                  <a:r>
+                    <a:rPr lang="en-US" sz="1600" dirty="0"/>
+                    <a:t> </a:t>
+                  </a:r>
+                  <a:r>
+                    <a:rPr lang="en-US" sz="1600" dirty="0">
+                      <a:solidFill>
+                        <a:schemeClr val="accent6">
+                          <a:lumMod val="75000"/>
+                        </a:schemeClr>
+                      </a:solidFill>
+                    </a:rPr>
+                    <a:t>wordlines</a:t>
+                  </a:r>
+                </a:p>
+              </p:txBody>
+            </p:sp>
+          </mc:Choice>
+          <mc:Fallback>
+            <p:sp>
+              <p:nvSpPr>
+                <p:cNvPr id="24" name="TextBox 23">
+                  <a:extLst>
+                    <a:ext uri="{FF2B5EF4-FFF2-40B4-BE49-F238E27FC236}">
+                      <a16:creationId xmlns:a16="http://schemas.microsoft.com/office/drawing/2014/main" id="{ED36180D-2EDA-541A-94AF-D513A7E12E55}"/>
+                    </a:ext>
+                  </a:extLst>
+                </p:cNvPr>
+                <p:cNvSpPr txBox="1">
+                  <a:spLocks noRot="1" noChangeAspect="1" noMove="1" noResize="1" noEditPoints="1" noAdjustHandles="1" noChangeArrowheads="1" noChangeShapeType="1" noTextEdit="1"/>
+                </p:cNvSpPr>
+                <p:nvPr/>
+              </p:nvSpPr>
+              <p:spPr>
+                <a:xfrm>
+                  <a:off x="1643390" y="3747300"/>
+                  <a:ext cx="1350050" cy="1077218"/>
+                </a:xfrm>
+                <a:prstGeom prst="rect">
+                  <a:avLst/>
+                </a:prstGeom>
+                <a:blipFill>
+                  <a:blip r:embed="rId4"/>
+                  <a:stretch>
+                    <a:fillRect l="-2715" t="-1705" r="-905" b="-6818"/>
+                  </a:stretch>
+                </a:blipFill>
+              </p:spPr>
+              <p:txBody>
+                <a:bodyPr/>
+                <a:lstStyle/>
+                <a:p>
+                  <a:r>
+                    <a:rPr lang="en-US">
+                      <a:noFill/>
+                    </a:rPr>
+                    <a:t> </a:t>
+                  </a:r>
+                </a:p>
+              </p:txBody>
+            </p:sp>
+          </mc:Fallback>
+        </mc:AlternateContent>
+        <mc:AlternateContent xmlns:mc="http://schemas.openxmlformats.org/markup-compatibility/2006">
+          <mc:Choice xmlns:a14="http://schemas.microsoft.com/office/drawing/2010/main" Requires="a14">
+            <p:sp>
+              <p:nvSpPr>
+                <p:cNvPr id="25" name="TextBox 24">
+                  <a:extLst>
+                    <a:ext uri="{FF2B5EF4-FFF2-40B4-BE49-F238E27FC236}">
+                      <a16:creationId xmlns:a16="http://schemas.microsoft.com/office/drawing/2014/main" id="{0527EA86-35F3-424D-82DB-21531A48F3B9}"/>
+                    </a:ext>
+                  </a:extLst>
+                </p:cNvPr>
+                <p:cNvSpPr txBox="1"/>
+                <p:nvPr/>
+              </p:nvSpPr>
+              <p:spPr>
+                <a:xfrm>
+                  <a:off x="2197380" y="1990396"/>
+                  <a:ext cx="1201226" cy="338554"/>
+                </a:xfrm>
+                <a:prstGeom prst="rect">
+                  <a:avLst/>
+                </a:prstGeom>
+                <a:noFill/>
+              </p:spPr>
+              <p:txBody>
+                <a:bodyPr wrap="none" rtlCol="0">
+                  <a:spAutoFit/>
+                </a:bodyPr>
+                <a:lstStyle/>
+                <a:p>
+                  <a14:m>
+                    <m:oMath xmlns:m="http://schemas.openxmlformats.org/officeDocument/2006/math">
+                      <m:r>
+                        <a:rPr lang="en-US" sz="1600" b="0" i="1" smtClean="0">
+                          <a:latin typeface="Cambria Math" panose="02040503050406030204" pitchFamily="18" charset="0"/>
+                        </a:rPr>
+                        <m:t>𝑁</m:t>
+                      </m:r>
+                    </m:oMath>
+                  </a14:m>
+                  <a:r>
+                    <a:rPr lang="en-US" sz="1600" dirty="0"/>
+                    <a:t> </a:t>
+                  </a:r>
+                  <a:r>
+                    <a:rPr lang="en-US" sz="1600" dirty="0">
+                      <a:solidFill>
+                        <a:schemeClr val="accent6">
+                          <a:lumMod val="75000"/>
+                        </a:schemeClr>
+                      </a:solidFill>
+                    </a:rPr>
+                    <a:t>wordlines</a:t>
+                  </a:r>
+                </a:p>
+              </p:txBody>
+            </p:sp>
+          </mc:Choice>
+          <mc:Fallback>
+            <p:sp>
+              <p:nvSpPr>
+                <p:cNvPr id="25" name="TextBox 24">
+                  <a:extLst>
+                    <a:ext uri="{FF2B5EF4-FFF2-40B4-BE49-F238E27FC236}">
+                      <a16:creationId xmlns:a16="http://schemas.microsoft.com/office/drawing/2014/main" id="{0527EA86-35F3-424D-82DB-21531A48F3B9}"/>
+                    </a:ext>
+                  </a:extLst>
+                </p:cNvPr>
+                <p:cNvSpPr txBox="1">
+                  <a:spLocks noRot="1" noChangeAspect="1" noMove="1" noResize="1" noEditPoints="1" noAdjustHandles="1" noChangeArrowheads="1" noChangeShapeType="1" noTextEdit="1"/>
+                </p:cNvSpPr>
+                <p:nvPr/>
+              </p:nvSpPr>
+              <p:spPr>
+                <a:xfrm>
+                  <a:off x="2197380" y="1990396"/>
+                  <a:ext cx="1201226" cy="338554"/>
+                </a:xfrm>
+                <a:prstGeom prst="rect">
+                  <a:avLst/>
+                </a:prstGeom>
+                <a:blipFill>
+                  <a:blip r:embed="rId5"/>
+                  <a:stretch>
+                    <a:fillRect t="-5455" r="-1515" b="-23636"/>
+                  </a:stretch>
+                </a:blipFill>
+              </p:spPr>
+              <p:txBody>
+                <a:bodyPr/>
+                <a:lstStyle/>
+                <a:p>
+                  <a:r>
+                    <a:rPr lang="en-US">
+                      <a:noFill/>
+                    </a:rPr>
+                    <a:t> </a:t>
+                  </a:r>
+                </a:p>
+              </p:txBody>
+            </p:sp>
+          </mc:Fallback>
+        </mc:AlternateContent>
+        <mc:AlternateContent xmlns:mc="http://schemas.openxmlformats.org/markup-compatibility/2006">
+          <mc:Choice xmlns:a14="http://schemas.microsoft.com/office/drawing/2010/main" Requires="a14">
+            <p:sp>
+              <p:nvSpPr>
+                <p:cNvPr id="33" name="TextBox 32">
+                  <a:extLst>
+                    <a:ext uri="{FF2B5EF4-FFF2-40B4-BE49-F238E27FC236}">
+                      <a16:creationId xmlns:a16="http://schemas.microsoft.com/office/drawing/2014/main" id="{0F464507-89E5-BDF2-C5B1-B406436F7580}"/>
+                    </a:ext>
+                  </a:extLst>
+                </p:cNvPr>
+                <p:cNvSpPr txBox="1"/>
+                <p:nvPr/>
+              </p:nvSpPr>
+              <p:spPr>
+                <a:xfrm>
+                  <a:off x="4190176" y="3473352"/>
+                  <a:ext cx="349775" cy="461665"/>
+                </a:xfrm>
+                <a:prstGeom prst="rect">
+                  <a:avLst/>
+                </a:prstGeom>
+                <a:noFill/>
+              </p:spPr>
+              <p:txBody>
+                <a:bodyPr wrap="none" rtlCol="0">
+                  <a:spAutoFit/>
+                </a:bodyPr>
+                <a:lstStyle/>
+                <a:p>
+                  <a:pPr/>
+                  <a14:m>
+                    <m:oMathPara xmlns:m="http://schemas.openxmlformats.org/officeDocument/2006/math">
+                      <m:oMathParaPr>
+                        <m:jc m:val="centerGroup"/>
+                      </m:oMathParaPr>
+                      <m:oMath xmlns:m="http://schemas.openxmlformats.org/officeDocument/2006/math">
+                        <m:r>
+                          <a:rPr lang="en-US" sz="2400" b="0" i="1" smtClean="0">
+                            <a:solidFill>
+                              <a:schemeClr val="accent1">
+                                <a:lumMod val="60000"/>
+                                <a:lumOff val="40000"/>
+                              </a:schemeClr>
+                            </a:solidFill>
+                            <a:latin typeface="Cambria Math" panose="02040503050406030204" pitchFamily="18" charset="0"/>
+                          </a:rPr>
+                          <m:t>⋮</m:t>
+                        </m:r>
+                      </m:oMath>
+                    </m:oMathPara>
+                  </a14:m>
+                  <a:endParaRPr lang="en-US" sz="2400" dirty="0">
+                    <a:solidFill>
+                      <a:schemeClr val="accent1">
+                        <a:lumMod val="60000"/>
+                        <a:lumOff val="40000"/>
+                      </a:schemeClr>
+                    </a:solidFill>
+                  </a:endParaRPr>
+                </a:p>
+              </p:txBody>
+            </p:sp>
+          </mc:Choice>
+          <mc:Fallback>
+            <p:sp>
+              <p:nvSpPr>
+                <p:cNvPr id="33" name="TextBox 32">
+                  <a:extLst>
+                    <a:ext uri="{FF2B5EF4-FFF2-40B4-BE49-F238E27FC236}">
+                      <a16:creationId xmlns:a16="http://schemas.microsoft.com/office/drawing/2014/main" id="{0F464507-89E5-BDF2-C5B1-B406436F7580}"/>
+                    </a:ext>
+                  </a:extLst>
+                </p:cNvPr>
+                <p:cNvSpPr txBox="1">
+                  <a:spLocks noRot="1" noChangeAspect="1" noMove="1" noResize="1" noEditPoints="1" noAdjustHandles="1" noChangeArrowheads="1" noChangeShapeType="1" noTextEdit="1"/>
+                </p:cNvSpPr>
+                <p:nvPr/>
+              </p:nvSpPr>
+              <p:spPr>
+                <a:xfrm>
+                  <a:off x="4190176" y="3473352"/>
+                  <a:ext cx="349775" cy="461665"/>
+                </a:xfrm>
+                <a:prstGeom prst="rect">
+                  <a:avLst/>
+                </a:prstGeom>
+                <a:blipFill>
+                  <a:blip r:embed="rId6"/>
+                  <a:stretch>
+                    <a:fillRect/>
+                  </a:stretch>
+                </a:blipFill>
+              </p:spPr>
+              <p:txBody>
+                <a:bodyPr/>
+                <a:lstStyle/>
+                <a:p>
+                  <a:r>
+                    <a:rPr lang="en-US">
+                      <a:noFill/>
+                    </a:rPr>
+                    <a:t> </a:t>
+                  </a:r>
+                </a:p>
+              </p:txBody>
+            </p:sp>
+          </mc:Fallback>
+        </mc:AlternateContent>
+        <mc:AlternateContent xmlns:mc="http://schemas.openxmlformats.org/markup-compatibility/2006">
+          <mc:Choice xmlns:a14="http://schemas.microsoft.com/office/drawing/2010/main" Requires="a14">
+            <p:sp>
+              <p:nvSpPr>
+                <p:cNvPr id="34" name="TextBox 33">
+                  <a:extLst>
+                    <a:ext uri="{FF2B5EF4-FFF2-40B4-BE49-F238E27FC236}">
+                      <a16:creationId xmlns:a16="http://schemas.microsoft.com/office/drawing/2014/main" id="{F1DBB8A8-5A6E-D7C3-0CF7-7F2498B56FE4}"/>
+                    </a:ext>
+                  </a:extLst>
+                </p:cNvPr>
+                <p:cNvSpPr txBox="1"/>
+                <p:nvPr/>
+              </p:nvSpPr>
+              <p:spPr>
+                <a:xfrm>
+                  <a:off x="3340700" y="3545028"/>
+                  <a:ext cx="349775" cy="461665"/>
+                </a:xfrm>
+                <a:prstGeom prst="rect">
+                  <a:avLst/>
+                </a:prstGeom>
+                <a:noFill/>
+              </p:spPr>
+              <p:txBody>
+                <a:bodyPr wrap="none" rtlCol="0">
+                  <a:spAutoFit/>
+                </a:bodyPr>
+                <a:lstStyle/>
+                <a:p>
+                  <a:pPr/>
+                  <a14:m>
+                    <m:oMathPara xmlns:m="http://schemas.openxmlformats.org/officeDocument/2006/math">
+                      <m:oMathParaPr>
+                        <m:jc m:val="centerGroup"/>
+                      </m:oMathParaPr>
+                      <m:oMath xmlns:m="http://schemas.openxmlformats.org/officeDocument/2006/math">
+                        <m:r>
+                          <a:rPr lang="en-US" sz="2400" b="0" i="1" smtClean="0">
+                            <a:solidFill>
+                              <a:schemeClr val="accent1">
+                                <a:lumMod val="60000"/>
+                                <a:lumOff val="40000"/>
+                              </a:schemeClr>
+                            </a:solidFill>
+                            <a:latin typeface="Cambria Math" panose="02040503050406030204" pitchFamily="18" charset="0"/>
+                          </a:rPr>
+                          <m:t>⋮</m:t>
+                        </m:r>
+                      </m:oMath>
+                    </m:oMathPara>
+                  </a14:m>
+                  <a:endParaRPr lang="en-US" sz="2400" dirty="0">
+                    <a:solidFill>
+                      <a:schemeClr val="accent1">
+                        <a:lumMod val="60000"/>
+                        <a:lumOff val="40000"/>
+                      </a:schemeClr>
+                    </a:solidFill>
+                  </a:endParaRPr>
+                </a:p>
+              </p:txBody>
+            </p:sp>
+          </mc:Choice>
+          <mc:Fallback>
+            <p:sp>
+              <p:nvSpPr>
+                <p:cNvPr id="34" name="TextBox 33">
+                  <a:extLst>
+                    <a:ext uri="{FF2B5EF4-FFF2-40B4-BE49-F238E27FC236}">
+                      <a16:creationId xmlns:a16="http://schemas.microsoft.com/office/drawing/2014/main" id="{F1DBB8A8-5A6E-D7C3-0CF7-7F2498B56FE4}"/>
+                    </a:ext>
+                  </a:extLst>
+                </p:cNvPr>
+                <p:cNvSpPr txBox="1">
+                  <a:spLocks noRot="1" noChangeAspect="1" noMove="1" noResize="1" noEditPoints="1" noAdjustHandles="1" noChangeArrowheads="1" noChangeShapeType="1" noTextEdit="1"/>
+                </p:cNvSpPr>
+                <p:nvPr/>
+              </p:nvSpPr>
+              <p:spPr>
+                <a:xfrm>
+                  <a:off x="3340700" y="3545028"/>
+                  <a:ext cx="349775" cy="461665"/>
+                </a:xfrm>
+                <a:prstGeom prst="rect">
+                  <a:avLst/>
+                </a:prstGeom>
+                <a:blipFill>
+                  <a:blip r:embed="rId7"/>
+                  <a:stretch>
+                    <a:fillRect/>
+                  </a:stretch>
+                </a:blipFill>
+              </p:spPr>
+              <p:txBody>
+                <a:bodyPr/>
+                <a:lstStyle/>
+                <a:p>
+                  <a:r>
+                    <a:rPr lang="en-US">
+                      <a:noFill/>
+                    </a:rPr>
+                    <a:t> </a:t>
+                  </a:r>
+                </a:p>
+              </p:txBody>
+            </p:sp>
+          </mc:Fallback>
+        </mc:AlternateContent>
+        <p:grpSp>
+          <p:nvGrpSpPr>
+            <p:cNvPr id="61" name="Group 60">
+              <a:extLst>
+                <a:ext uri="{FF2B5EF4-FFF2-40B4-BE49-F238E27FC236}">
+                  <a16:creationId xmlns:a16="http://schemas.microsoft.com/office/drawing/2014/main" id="{EF733FA4-307B-C512-F380-F8D34A28BA50}"/>
+                </a:ext>
+              </a:extLst>
+            </p:cNvPr>
+            <p:cNvGrpSpPr/>
+            <p:nvPr/>
+          </p:nvGrpSpPr>
+          <p:grpSpPr>
+            <a:xfrm>
+              <a:off x="3167386" y="2308781"/>
+              <a:ext cx="2397325" cy="296148"/>
+              <a:chOff x="3167386" y="2308781"/>
+              <a:chExt cx="2397325" cy="296148"/>
+            </a:xfrm>
+          </p:grpSpPr>
+          <p:cxnSp>
+            <p:nvCxnSpPr>
+              <p:cNvPr id="13" name="Straight Arrow Connector 12">
+                <a:extLst>
+                  <a:ext uri="{FF2B5EF4-FFF2-40B4-BE49-F238E27FC236}">
+                    <a16:creationId xmlns:a16="http://schemas.microsoft.com/office/drawing/2014/main" id="{9A6A75BD-5C70-CFFA-DD52-79FD0A8AD965}"/>
+                  </a:ext>
+                </a:extLst>
+              </p:cNvPr>
+              <p:cNvCxnSpPr/>
+              <p:nvPr/>
+            </p:nvCxnSpPr>
+            <p:spPr>
+              <a:xfrm>
+                <a:off x="3167386" y="2472526"/>
+                <a:ext cx="738563" cy="0"/>
+              </a:xfrm>
+              <a:prstGeom prst="straightConnector1">
+                <a:avLst/>
+              </a:prstGeom>
+              <a:ln>
+                <a:solidFill>
+                  <a:schemeClr val="accent6">
+                    <a:lumMod val="75000"/>
+                  </a:schemeClr>
+                </a:solidFill>
+                <a:tailEnd type="triangle"/>
+              </a:ln>
+            </p:spPr>
+            <p:style>
+              <a:lnRef idx="1">
+                <a:schemeClr val="accent1"/>
+              </a:lnRef>
+              <a:fillRef idx="0">
+                <a:schemeClr val="accent1"/>
+              </a:fillRef>
+              <a:effectRef idx="0">
+                <a:schemeClr val="accent1"/>
+              </a:effectRef>
+              <a:fontRef idx="minor">
+                <a:schemeClr val="tx1"/>
+              </a:fontRef>
+            </p:style>
+          </p:cxnSp>
+          <p:sp>
+            <p:nvSpPr>
+              <p:cNvPr id="14" name="Rectangle 13">
+                <a:extLst>
+                  <a:ext uri="{FF2B5EF4-FFF2-40B4-BE49-F238E27FC236}">
+                    <a16:creationId xmlns:a16="http://schemas.microsoft.com/office/drawing/2014/main" id="{AB523CD0-BADD-C065-EFF8-D48B3E63BD0D}"/>
+                  </a:ext>
+                </a:extLst>
+              </p:cNvPr>
+              <p:cNvSpPr/>
+              <p:nvPr/>
+            </p:nvSpPr>
+            <p:spPr>
+              <a:xfrm>
+                <a:off x="3911748" y="2308781"/>
+                <a:ext cx="914400" cy="296148"/>
+              </a:xfrm>
+              <a:prstGeom prst="rect">
+                <a:avLst/>
+              </a:prstGeom>
+              <a:noFill/>
+            </p:spPr>
+            <p:style>
+              <a:lnRef idx="2">
+                <a:schemeClr val="accent1">
+                  <a:shade val="15000"/>
+                </a:schemeClr>
+              </a:lnRef>
+              <a:fillRef idx="1">
+                <a:schemeClr val="accent1"/>
+              </a:fillRef>
+              <a:effectRef idx="0">
+                <a:schemeClr val="accent1"/>
+              </a:effectRef>
+              <a:fontRef idx="minor">
+                <a:schemeClr val="lt1"/>
+              </a:fontRef>
+            </p:style>
+            <p:txBody>
+              <a:bodyPr rtlCol="0" anchor="ctr"/>
+              <a:lstStyle/>
+              <a:p>
+                <a:pPr algn="ctr"/>
+                <a:endParaRPr lang="en-US"/>
+              </a:p>
+            </p:txBody>
+          </p:sp>
+          <p:cxnSp>
+            <p:nvCxnSpPr>
+              <p:cNvPr id="35" name="Straight Arrow Connector 34">
+                <a:extLst>
+                  <a:ext uri="{FF2B5EF4-FFF2-40B4-BE49-F238E27FC236}">
+                    <a16:creationId xmlns:a16="http://schemas.microsoft.com/office/drawing/2014/main" id="{A8788F5C-FDF1-39CC-0D44-A53EBE14875A}"/>
+                  </a:ext>
+                </a:extLst>
+              </p:cNvPr>
+              <p:cNvCxnSpPr/>
+              <p:nvPr/>
+            </p:nvCxnSpPr>
+            <p:spPr>
+              <a:xfrm>
+                <a:off x="4826148" y="2507810"/>
+                <a:ext cx="738563" cy="0"/>
+              </a:xfrm>
+              <a:prstGeom prst="straightConnector1">
+                <a:avLst/>
+              </a:prstGeom>
+              <a:ln>
+                <a:solidFill>
+                  <a:srgbClr val="00B050"/>
+                </a:solidFill>
+                <a:headEnd type="triangle"/>
+                <a:tailEnd type="triangle"/>
+              </a:ln>
+            </p:spPr>
+            <p:style>
+              <a:lnRef idx="1">
+                <a:schemeClr val="accent1"/>
+              </a:lnRef>
+              <a:fillRef idx="0">
+                <a:schemeClr val="accent1"/>
+              </a:fillRef>
+              <a:effectRef idx="0">
+                <a:schemeClr val="accent1"/>
+              </a:effectRef>
+              <a:fontRef idx="minor">
+                <a:schemeClr val="tx1"/>
+              </a:fontRef>
+            </p:style>
+          </p:cxnSp>
+          <p:cxnSp>
+            <p:nvCxnSpPr>
+              <p:cNvPr id="36" name="Straight Arrow Connector 35">
+                <a:extLst>
+                  <a:ext uri="{FF2B5EF4-FFF2-40B4-BE49-F238E27FC236}">
+                    <a16:creationId xmlns:a16="http://schemas.microsoft.com/office/drawing/2014/main" id="{782C58E0-CB61-DFD4-D0C8-34BE336673A6}"/>
+                  </a:ext>
+                </a:extLst>
+              </p:cNvPr>
+              <p:cNvCxnSpPr>
+                <a:cxnSpLocks/>
+              </p:cNvCxnSpPr>
+              <p:nvPr/>
+            </p:nvCxnSpPr>
+            <p:spPr>
+              <a:xfrm flipH="1">
+                <a:off x="4826148" y="2406103"/>
+                <a:ext cx="381245" cy="0"/>
+              </a:xfrm>
+              <a:prstGeom prst="straightConnector1">
+                <a:avLst/>
+              </a:prstGeom>
+              <a:ln>
+                <a:tailEnd type="triangle"/>
+              </a:ln>
+            </p:spPr>
+            <p:style>
+              <a:lnRef idx="1">
+                <a:schemeClr val="accent1"/>
+              </a:lnRef>
+              <a:fillRef idx="0">
+                <a:schemeClr val="accent1"/>
+              </a:fillRef>
+              <a:effectRef idx="0">
+                <a:schemeClr val="accent1"/>
+              </a:effectRef>
+              <a:fontRef idx="minor">
+                <a:schemeClr val="tx1"/>
+              </a:fontRef>
+            </p:style>
+          </p:cxnSp>
+        </p:grpSp>
+        <p:cxnSp>
+          <p:nvCxnSpPr>
+            <p:cNvPr id="46" name="Straight Arrow Connector 45">
+              <a:extLst>
+                <a:ext uri="{FF2B5EF4-FFF2-40B4-BE49-F238E27FC236}">
+                  <a16:creationId xmlns:a16="http://schemas.microsoft.com/office/drawing/2014/main" id="{6101463D-2ED4-556F-8691-B8F78C6B7597}"/>
+                </a:ext>
+              </a:extLst>
+            </p:cNvPr>
+            <p:cNvCxnSpPr/>
+            <p:nvPr/>
+          </p:nvCxnSpPr>
+          <p:spPr>
+            <a:xfrm>
+              <a:off x="3172180" y="3068867"/>
+              <a:ext cx="738563" cy="0"/>
+            </a:xfrm>
+            <a:prstGeom prst="straightConnector1">
+              <a:avLst/>
+            </a:prstGeom>
+            <a:ln w="25400">
+              <a:solidFill>
+                <a:schemeClr val="accent5">
+                  <a:lumMod val="50000"/>
                 </a:schemeClr>
               </a:solidFill>
               <a:tailEnd type="triangle"/>
@@ -31064,10 +31260,10 @@
         </p:cxnSp>
         <p:sp>
           <p:nvSpPr>
-            <p:cNvPr id="14" name="Rectangle 13">
+            <p:cNvPr id="47" name="Rectangle 46">
               <a:extLst>
                 <a:ext uri="{FF2B5EF4-FFF2-40B4-BE49-F238E27FC236}">
-                  <a16:creationId xmlns:a16="http://schemas.microsoft.com/office/drawing/2014/main" id="{AB523CD0-BADD-C065-EFF8-D48B3E63BD0D}"/>
+                  <a16:creationId xmlns:a16="http://schemas.microsoft.com/office/drawing/2014/main" id="{C6FE01C0-9FFA-6EAB-73B5-1D143D273C08}"/>
                 </a:ext>
               </a:extLst>
             </p:cNvPr>
@@ -31076,7 +31272,7 @@
           </p:nvSpPr>
           <p:spPr>
             <a:xfrm>
-              <a:off x="3911748" y="2308781"/>
+              <a:off x="3909916" y="2905122"/>
               <a:ext cx="914400" cy="296148"/>
             </a:xfrm>
             <a:prstGeom prst="rect">
@@ -31111,10 +31307,10 @@
         </p:sp>
         <p:cxnSp>
           <p:nvCxnSpPr>
-            <p:cNvPr id="35" name="Straight Arrow Connector 34">
+            <p:cNvPr id="48" name="Straight Arrow Connector 47">
               <a:extLst>
                 <a:ext uri="{FF2B5EF4-FFF2-40B4-BE49-F238E27FC236}">
-                  <a16:creationId xmlns:a16="http://schemas.microsoft.com/office/drawing/2014/main" id="{A8788F5C-FDF1-39CC-0D44-A53EBE14875A}"/>
+                  <a16:creationId xmlns:a16="http://schemas.microsoft.com/office/drawing/2014/main" id="{8AE36616-2713-6219-9197-77F22DB27C13}"/>
                 </a:ext>
               </a:extLst>
             </p:cNvPr>
@@ -31123,7 +31319,7 @@
           </p:nvCxnSpPr>
           <p:spPr>
             <a:xfrm>
-              <a:off x="4826148" y="2507810"/>
+              <a:off x="4830942" y="3104151"/>
               <a:ext cx="738563" cy="0"/>
             </a:xfrm>
             <a:prstGeom prst="straightConnector1">
@@ -31154,10 +31350,10 @@
         </p:cxnSp>
         <p:cxnSp>
           <p:nvCxnSpPr>
-            <p:cNvPr id="36" name="Straight Arrow Connector 35">
+            <p:cNvPr id="49" name="Straight Arrow Connector 48">
               <a:extLst>
                 <a:ext uri="{FF2B5EF4-FFF2-40B4-BE49-F238E27FC236}">
-                  <a16:creationId xmlns:a16="http://schemas.microsoft.com/office/drawing/2014/main" id="{782C58E0-CB61-DFD4-D0C8-34BE336673A6}"/>
+                  <a16:creationId xmlns:a16="http://schemas.microsoft.com/office/drawing/2014/main" id="{2296EBF3-3686-997A-895D-A805E1B38824}"/>
                 </a:ext>
               </a:extLst>
             </p:cNvPr>
@@ -31168,7 +31364,7 @@
           </p:nvCxnSpPr>
           <p:spPr>
             <a:xfrm flipH="1">
-              <a:off x="4826148" y="2406103"/>
+              <a:off x="4830942" y="3002444"/>
               <a:ext cx="381245" cy="0"/>
             </a:xfrm>
             <a:prstGeom prst="straightConnector1">
@@ -31193,364 +31389,32 @@
             </a:fontRef>
           </p:style>
         </p:cxnSp>
-      </p:grpSp>
-      <p:cxnSp>
-        <p:nvCxnSpPr>
-          <p:cNvPr id="46" name="Straight Arrow Connector 45">
-            <a:extLst>
-              <a:ext uri="{FF2B5EF4-FFF2-40B4-BE49-F238E27FC236}">
-                <a16:creationId xmlns:a16="http://schemas.microsoft.com/office/drawing/2014/main" id="{6101463D-2ED4-556F-8691-B8F78C6B7597}"/>
-              </a:ext>
-            </a:extLst>
-          </p:cNvPr>
-          <p:cNvCxnSpPr/>
-          <p:nvPr/>
-        </p:nvCxnSpPr>
-        <p:spPr>
-          <a:xfrm>
-            <a:off x="3172180" y="3068867"/>
-            <a:ext cx="738563" cy="0"/>
-          </a:xfrm>
-          <a:prstGeom prst="straightConnector1">
-            <a:avLst/>
-          </a:prstGeom>
-          <a:ln w="25400">
-            <a:solidFill>
-              <a:schemeClr val="accent5">
-                <a:lumMod val="50000"/>
-              </a:schemeClr>
-            </a:solidFill>
-            <a:tailEnd type="triangle"/>
-          </a:ln>
-        </p:spPr>
-        <p:style>
-          <a:lnRef idx="1">
-            <a:schemeClr val="accent1"/>
-          </a:lnRef>
-          <a:fillRef idx="0">
-            <a:schemeClr val="accent1"/>
-          </a:fillRef>
-          <a:effectRef idx="0">
-            <a:schemeClr val="accent1"/>
-          </a:effectRef>
-          <a:fontRef idx="minor">
-            <a:schemeClr val="tx1"/>
-          </a:fontRef>
-        </p:style>
-      </p:cxnSp>
-      <p:sp>
-        <p:nvSpPr>
-          <p:cNvPr id="47" name="Rectangle 46">
-            <a:extLst>
-              <a:ext uri="{FF2B5EF4-FFF2-40B4-BE49-F238E27FC236}">
-                <a16:creationId xmlns:a16="http://schemas.microsoft.com/office/drawing/2014/main" id="{C6FE01C0-9FFA-6EAB-73B5-1D143D273C08}"/>
-              </a:ext>
-            </a:extLst>
-          </p:cNvPr>
-          <p:cNvSpPr/>
-          <p:nvPr/>
-        </p:nvSpPr>
-        <p:spPr>
-          <a:xfrm>
-            <a:off x="3909916" y="2905122"/>
-            <a:ext cx="914400" cy="296148"/>
-          </a:xfrm>
-          <a:prstGeom prst="rect">
-            <a:avLst/>
-          </a:prstGeom>
-          <a:noFill/>
-        </p:spPr>
-        <p:style>
-          <a:lnRef idx="2">
-            <a:schemeClr val="accent1">
-              <a:shade val="15000"/>
-            </a:schemeClr>
-          </a:lnRef>
-          <a:fillRef idx="1">
-            <a:schemeClr val="accent1"/>
-          </a:fillRef>
-          <a:effectRef idx="0">
-            <a:schemeClr val="accent1"/>
-          </a:effectRef>
-          <a:fontRef idx="minor">
-            <a:schemeClr val="lt1"/>
-          </a:fontRef>
-        </p:style>
-        <p:txBody>
-          <a:bodyPr rtlCol="0" anchor="ctr"/>
-          <a:lstStyle/>
-          <a:p>
-            <a:pPr algn="ctr"/>
-            <a:endParaRPr lang="en-US"/>
-          </a:p>
-        </p:txBody>
-      </p:sp>
-      <p:cxnSp>
-        <p:nvCxnSpPr>
-          <p:cNvPr id="48" name="Straight Arrow Connector 47">
-            <a:extLst>
-              <a:ext uri="{FF2B5EF4-FFF2-40B4-BE49-F238E27FC236}">
-                <a16:creationId xmlns:a16="http://schemas.microsoft.com/office/drawing/2014/main" id="{8AE36616-2713-6219-9197-77F22DB27C13}"/>
-              </a:ext>
-            </a:extLst>
-          </p:cNvPr>
-          <p:cNvCxnSpPr/>
-          <p:nvPr/>
-        </p:nvCxnSpPr>
-        <p:spPr>
-          <a:xfrm>
-            <a:off x="4830942" y="3104151"/>
-            <a:ext cx="738563" cy="0"/>
-          </a:xfrm>
-          <a:prstGeom prst="straightConnector1">
-            <a:avLst/>
-          </a:prstGeom>
-          <a:ln>
-            <a:solidFill>
-              <a:srgbClr val="00B050"/>
-            </a:solidFill>
-            <a:headEnd type="triangle"/>
-            <a:tailEnd type="triangle"/>
-          </a:ln>
-        </p:spPr>
-        <p:style>
-          <a:lnRef idx="1">
-            <a:schemeClr val="accent1"/>
-          </a:lnRef>
-          <a:fillRef idx="0">
-            <a:schemeClr val="accent1"/>
-          </a:fillRef>
-          <a:effectRef idx="0">
-            <a:schemeClr val="accent1"/>
-          </a:effectRef>
-          <a:fontRef idx="minor">
-            <a:schemeClr val="tx1"/>
-          </a:fontRef>
-        </p:style>
-      </p:cxnSp>
-      <p:cxnSp>
-        <p:nvCxnSpPr>
-          <p:cNvPr id="49" name="Straight Arrow Connector 48">
-            <a:extLst>
-              <a:ext uri="{FF2B5EF4-FFF2-40B4-BE49-F238E27FC236}">
-                <a16:creationId xmlns:a16="http://schemas.microsoft.com/office/drawing/2014/main" id="{2296EBF3-3686-997A-895D-A805E1B38824}"/>
-              </a:ext>
-            </a:extLst>
-          </p:cNvPr>
-          <p:cNvCxnSpPr>
-            <a:cxnSpLocks/>
-          </p:cNvCxnSpPr>
-          <p:nvPr/>
-        </p:nvCxnSpPr>
-        <p:spPr>
-          <a:xfrm flipH="1">
-            <a:off x="4830942" y="3002444"/>
-            <a:ext cx="381245" cy="0"/>
-          </a:xfrm>
-          <a:prstGeom prst="straightConnector1">
-            <a:avLst/>
-          </a:prstGeom>
-          <a:ln>
-            <a:tailEnd type="triangle"/>
-          </a:ln>
-        </p:spPr>
-        <p:style>
-          <a:lnRef idx="1">
-            <a:schemeClr val="accent1"/>
-          </a:lnRef>
-          <a:fillRef idx="0">
-            <a:schemeClr val="accent1"/>
-          </a:fillRef>
-          <a:effectRef idx="0">
-            <a:schemeClr val="accent1"/>
-          </a:effectRef>
-          <a:fontRef idx="minor">
-            <a:schemeClr val="tx1"/>
-          </a:fontRef>
-        </p:style>
-      </p:cxnSp>
-      <p:cxnSp>
-        <p:nvCxnSpPr>
-          <p:cNvPr id="56" name="Straight Arrow Connector 55">
-            <a:extLst>
-              <a:ext uri="{FF2B5EF4-FFF2-40B4-BE49-F238E27FC236}">
-                <a16:creationId xmlns:a16="http://schemas.microsoft.com/office/drawing/2014/main" id="{547F1818-3246-6025-8F83-6642EAB316DC}"/>
-              </a:ext>
-            </a:extLst>
-          </p:cNvPr>
-          <p:cNvCxnSpPr>
-            <a:cxnSpLocks/>
-          </p:cNvCxnSpPr>
-          <p:nvPr/>
-        </p:nvCxnSpPr>
-        <p:spPr>
-          <a:xfrm>
-            <a:off x="2593770" y="3196939"/>
-            <a:ext cx="580242" cy="0"/>
-          </a:xfrm>
-          <a:prstGeom prst="straightConnector1">
-            <a:avLst/>
-          </a:prstGeom>
-          <a:ln>
-            <a:solidFill>
-              <a:schemeClr val="accent5">
-                <a:lumMod val="50000"/>
-              </a:schemeClr>
-            </a:solidFill>
-            <a:tailEnd type="triangle"/>
-          </a:ln>
-        </p:spPr>
-        <p:style>
-          <a:lnRef idx="1">
-            <a:schemeClr val="accent1"/>
-          </a:lnRef>
-          <a:fillRef idx="0">
-            <a:schemeClr val="accent1"/>
-          </a:fillRef>
-          <a:effectRef idx="0">
-            <a:schemeClr val="accent1"/>
-          </a:effectRef>
-          <a:fontRef idx="minor">
-            <a:schemeClr val="tx1"/>
-          </a:fontRef>
-        </p:style>
-      </p:cxnSp>
-      <p:cxnSp>
-        <p:nvCxnSpPr>
-          <p:cNvPr id="58" name="Straight Connector 57">
-            <a:extLst>
-              <a:ext uri="{FF2B5EF4-FFF2-40B4-BE49-F238E27FC236}">
-                <a16:creationId xmlns:a16="http://schemas.microsoft.com/office/drawing/2014/main" id="{2ADADB14-B164-1D09-68A4-0E5F78189626}"/>
-              </a:ext>
-            </a:extLst>
-          </p:cNvPr>
-          <p:cNvCxnSpPr>
-            <a:cxnSpLocks/>
-          </p:cNvCxnSpPr>
-          <p:nvPr/>
-        </p:nvCxnSpPr>
-        <p:spPr>
-          <a:xfrm flipH="1">
-            <a:off x="5194436" y="2169329"/>
-            <a:ext cx="12957" cy="2580694"/>
-          </a:xfrm>
-          <a:prstGeom prst="line">
-            <a:avLst/>
-          </a:prstGeom>
-        </p:spPr>
-        <p:style>
-          <a:lnRef idx="1">
-            <a:schemeClr val="accent1"/>
-          </a:lnRef>
-          <a:fillRef idx="0">
-            <a:schemeClr val="accent1"/>
-          </a:fillRef>
-          <a:effectRef idx="0">
-            <a:schemeClr val="accent1"/>
-          </a:effectRef>
-          <a:fontRef idx="minor">
-            <a:schemeClr val="tx1"/>
-          </a:fontRef>
-        </p:style>
-      </p:cxnSp>
-      <p:sp>
-        <p:nvSpPr>
-          <p:cNvPr id="60" name="TextBox 59">
-            <a:extLst>
-              <a:ext uri="{FF2B5EF4-FFF2-40B4-BE49-F238E27FC236}">
-                <a16:creationId xmlns:a16="http://schemas.microsoft.com/office/drawing/2014/main" id="{4AC00E66-F6DE-4763-C5D1-6A285C8F48AC}"/>
-              </a:ext>
-            </a:extLst>
-          </p:cNvPr>
-          <p:cNvSpPr txBox="1"/>
-          <p:nvPr/>
-        </p:nvSpPr>
-        <p:spPr>
-          <a:xfrm>
-            <a:off x="5446248" y="1630137"/>
-            <a:ext cx="571375" cy="584775"/>
-          </a:xfrm>
-          <a:prstGeom prst="rect">
-            <a:avLst/>
-          </a:prstGeom>
-          <a:noFill/>
-        </p:spPr>
-        <p:txBody>
-          <a:bodyPr wrap="none" rtlCol="0">
-            <a:spAutoFit/>
-          </a:bodyPr>
-          <a:lstStyle/>
-          <a:p>
-            <a:r>
-              <a:rPr lang="en-US" sz="1600" dirty="0">
-                <a:solidFill>
-                  <a:srgbClr val="00B050"/>
-                </a:solidFill>
-              </a:rPr>
-              <a:t>Data</a:t>
-            </a:r>
-            <a:br>
-              <a:rPr lang="en-US" sz="1600" dirty="0">
-                <a:solidFill>
-                  <a:srgbClr val="00B050"/>
-                </a:solidFill>
-              </a:rPr>
-            </a:br>
-            <a:r>
-              <a:rPr lang="en-US" sz="1600" dirty="0">
-                <a:solidFill>
-                  <a:srgbClr val="00B050"/>
-                </a:solidFill>
-              </a:rPr>
-              <a:t>Bus</a:t>
-            </a:r>
-          </a:p>
-        </p:txBody>
-      </p:sp>
-      <p:grpSp>
-        <p:nvGrpSpPr>
-          <p:cNvPr id="62" name="Group 61">
-            <a:extLst>
-              <a:ext uri="{FF2B5EF4-FFF2-40B4-BE49-F238E27FC236}">
-                <a16:creationId xmlns:a16="http://schemas.microsoft.com/office/drawing/2014/main" id="{03BE214C-0C61-D9C3-A14A-90EFDFD19676}"/>
-              </a:ext>
-            </a:extLst>
-          </p:cNvPr>
-          <p:cNvGrpSpPr/>
-          <p:nvPr/>
-        </p:nvGrpSpPr>
-        <p:grpSpPr>
-          <a:xfrm>
-            <a:off x="3163502" y="2605830"/>
-            <a:ext cx="2397325" cy="296148"/>
-            <a:chOff x="3167386" y="2308781"/>
-            <a:chExt cx="2397325" cy="296148"/>
-          </a:xfrm>
-        </p:grpSpPr>
         <p:cxnSp>
           <p:nvCxnSpPr>
-            <p:cNvPr id="63" name="Straight Arrow Connector 62">
+            <p:cNvPr id="56" name="Straight Arrow Connector 55">
               <a:extLst>
                 <a:ext uri="{FF2B5EF4-FFF2-40B4-BE49-F238E27FC236}">
-                  <a16:creationId xmlns:a16="http://schemas.microsoft.com/office/drawing/2014/main" id="{92A9608B-D09E-FC52-42A7-1255BEB8CDD5}"/>
+                  <a16:creationId xmlns:a16="http://schemas.microsoft.com/office/drawing/2014/main" id="{547F1818-3246-6025-8F83-6642EAB316DC}"/>
                 </a:ext>
               </a:extLst>
             </p:cNvPr>
-            <p:cNvCxnSpPr/>
+            <p:cNvCxnSpPr>
+              <a:cxnSpLocks/>
+            </p:cNvCxnSpPr>
             <p:nvPr/>
           </p:nvCxnSpPr>
           <p:spPr>
             <a:xfrm>
-              <a:off x="3167386" y="2472526"/>
-              <a:ext cx="738563" cy="0"/>
+              <a:off x="2593770" y="3196939"/>
+              <a:ext cx="580242" cy="0"/>
             </a:xfrm>
             <a:prstGeom prst="straightConnector1">
               <a:avLst/>
             </a:prstGeom>
             <a:ln>
               <a:solidFill>
-                <a:schemeClr val="accent6">
-                  <a:lumMod val="75000"/>
+                <a:schemeClr val="accent5">
+                  <a:lumMod val="50000"/>
                 </a:schemeClr>
               </a:solidFill>
               <a:tailEnd type="triangle"/>
@@ -31571,102 +31435,12 @@
             </a:fontRef>
           </p:style>
         </p:cxnSp>
-        <p:sp>
-          <p:nvSpPr>
-            <p:cNvPr id="64" name="Rectangle 63">
+        <p:cxnSp>
+          <p:nvCxnSpPr>
+            <p:cNvPr id="58" name="Straight Connector 57">
               <a:extLst>
                 <a:ext uri="{FF2B5EF4-FFF2-40B4-BE49-F238E27FC236}">
-                  <a16:creationId xmlns:a16="http://schemas.microsoft.com/office/drawing/2014/main" id="{B76BA245-15FD-6781-181D-1D5F2E63E6A2}"/>
-                </a:ext>
-              </a:extLst>
-            </p:cNvPr>
-            <p:cNvSpPr/>
-            <p:nvPr/>
-          </p:nvSpPr>
-          <p:spPr>
-            <a:xfrm>
-              <a:off x="3911748" y="2308781"/>
-              <a:ext cx="914400" cy="296148"/>
-            </a:xfrm>
-            <a:prstGeom prst="rect">
-              <a:avLst/>
-            </a:prstGeom>
-            <a:noFill/>
-          </p:spPr>
-          <p:style>
-            <a:lnRef idx="2">
-              <a:schemeClr val="accent1">
-                <a:shade val="15000"/>
-              </a:schemeClr>
-            </a:lnRef>
-            <a:fillRef idx="1">
-              <a:schemeClr val="accent1"/>
-            </a:fillRef>
-            <a:effectRef idx="0">
-              <a:schemeClr val="accent1"/>
-            </a:effectRef>
-            <a:fontRef idx="minor">
-              <a:schemeClr val="lt1"/>
-            </a:fontRef>
-          </p:style>
-          <p:txBody>
-            <a:bodyPr rtlCol="0" anchor="ctr"/>
-            <a:lstStyle/>
-            <a:p>
-              <a:pPr algn="ctr"/>
-              <a:endParaRPr lang="en-US"/>
-            </a:p>
-          </p:txBody>
-        </p:sp>
-        <p:cxnSp>
-          <p:nvCxnSpPr>
-            <p:cNvPr id="65" name="Straight Arrow Connector 64">
-              <a:extLst>
-                <a:ext uri="{FF2B5EF4-FFF2-40B4-BE49-F238E27FC236}">
-                  <a16:creationId xmlns:a16="http://schemas.microsoft.com/office/drawing/2014/main" id="{3769AB36-0F08-C5FE-886B-6B7DEE6DEAEC}"/>
-                </a:ext>
-              </a:extLst>
-            </p:cNvPr>
-            <p:cNvCxnSpPr/>
-            <p:nvPr/>
-          </p:nvCxnSpPr>
-          <p:spPr>
-            <a:xfrm>
-              <a:off x="4826148" y="2507810"/>
-              <a:ext cx="738563" cy="0"/>
-            </a:xfrm>
-            <a:prstGeom prst="straightConnector1">
-              <a:avLst/>
-            </a:prstGeom>
-            <a:ln>
-              <a:solidFill>
-                <a:srgbClr val="00B050"/>
-              </a:solidFill>
-              <a:headEnd type="triangle"/>
-              <a:tailEnd type="triangle"/>
-            </a:ln>
-          </p:spPr>
-          <p:style>
-            <a:lnRef idx="1">
-              <a:schemeClr val="accent1"/>
-            </a:lnRef>
-            <a:fillRef idx="0">
-              <a:schemeClr val="accent1"/>
-            </a:fillRef>
-            <a:effectRef idx="0">
-              <a:schemeClr val="accent1"/>
-            </a:effectRef>
-            <a:fontRef idx="minor">
-              <a:schemeClr val="tx1"/>
-            </a:fontRef>
-          </p:style>
-        </p:cxnSp>
-        <p:cxnSp>
-          <p:nvCxnSpPr>
-            <p:cNvPr id="66" name="Straight Arrow Connector 65">
-              <a:extLst>
-                <a:ext uri="{FF2B5EF4-FFF2-40B4-BE49-F238E27FC236}">
-                  <a16:creationId xmlns:a16="http://schemas.microsoft.com/office/drawing/2014/main" id="{A2061DEC-B635-5343-3CA1-DEC6B0902FC0}"/>
+                  <a16:creationId xmlns:a16="http://schemas.microsoft.com/office/drawing/2014/main" id="{2ADADB14-B164-1D09-68A4-0E5F78189626}"/>
                 </a:ext>
               </a:extLst>
             </p:cNvPr>
@@ -31677,80 +31451,12 @@
           </p:nvCxnSpPr>
           <p:spPr>
             <a:xfrm flipH="1">
-              <a:off x="4826148" y="2406103"/>
-              <a:ext cx="381245" cy="0"/>
+              <a:off x="5194436" y="2169329"/>
+              <a:ext cx="12957" cy="2580694"/>
             </a:xfrm>
-            <a:prstGeom prst="straightConnector1">
+            <a:prstGeom prst="line">
               <a:avLst/>
             </a:prstGeom>
-            <a:ln>
-              <a:tailEnd type="triangle"/>
-            </a:ln>
-          </p:spPr>
-          <p:style>
-            <a:lnRef idx="1">
-              <a:schemeClr val="accent1"/>
-            </a:lnRef>
-            <a:fillRef idx="0">
-              <a:schemeClr val="accent1"/>
-            </a:fillRef>
-            <a:effectRef idx="0">
-              <a:schemeClr val="accent1"/>
-            </a:effectRef>
-            <a:fontRef idx="minor">
-              <a:schemeClr val="tx1"/>
-            </a:fontRef>
-          </p:style>
-        </p:cxnSp>
-      </p:grpSp>
-      <p:grpSp>
-        <p:nvGrpSpPr>
-          <p:cNvPr id="67" name="Group 66">
-            <a:extLst>
-              <a:ext uri="{FF2B5EF4-FFF2-40B4-BE49-F238E27FC236}">
-                <a16:creationId xmlns:a16="http://schemas.microsoft.com/office/drawing/2014/main" id="{23C15D42-54C0-8F3D-9D02-372FD33F0E9D}"/>
-              </a:ext>
-            </a:extLst>
-          </p:cNvPr>
-          <p:cNvGrpSpPr/>
-          <p:nvPr/>
-        </p:nvGrpSpPr>
-        <p:grpSpPr>
-          <a:xfrm>
-            <a:off x="3150250" y="4652701"/>
-            <a:ext cx="2397325" cy="296148"/>
-            <a:chOff x="3167386" y="2308781"/>
-            <a:chExt cx="2397325" cy="296148"/>
-          </a:xfrm>
-        </p:grpSpPr>
-        <p:cxnSp>
-          <p:nvCxnSpPr>
-            <p:cNvPr id="68" name="Straight Arrow Connector 67">
-              <a:extLst>
-                <a:ext uri="{FF2B5EF4-FFF2-40B4-BE49-F238E27FC236}">
-                  <a16:creationId xmlns:a16="http://schemas.microsoft.com/office/drawing/2014/main" id="{844380C4-92E7-0497-592B-77D939FED30B}"/>
-                </a:ext>
-              </a:extLst>
-            </p:cNvPr>
-            <p:cNvCxnSpPr/>
-            <p:nvPr/>
-          </p:nvCxnSpPr>
-          <p:spPr>
-            <a:xfrm>
-              <a:off x="3167386" y="2472526"/>
-              <a:ext cx="738563" cy="0"/>
-            </a:xfrm>
-            <a:prstGeom prst="straightConnector1">
-              <a:avLst/>
-            </a:prstGeom>
-            <a:ln>
-              <a:solidFill>
-                <a:schemeClr val="accent6">
-                  <a:lumMod val="75000"/>
-                </a:schemeClr>
-              </a:solidFill>
-              <a:tailEnd type="triangle"/>
-            </a:ln>
           </p:spPr>
           <p:style>
             <a:lnRef idx="1">
@@ -31769,300 +31475,615 @@
         </p:cxnSp>
         <p:sp>
           <p:nvSpPr>
-            <p:cNvPr id="69" name="Rectangle 68">
+            <p:cNvPr id="60" name="TextBox 59">
               <a:extLst>
                 <a:ext uri="{FF2B5EF4-FFF2-40B4-BE49-F238E27FC236}">
-                  <a16:creationId xmlns:a16="http://schemas.microsoft.com/office/drawing/2014/main" id="{E9ADA6A9-A770-B752-D749-F9DA004178AB}"/>
+                  <a16:creationId xmlns:a16="http://schemas.microsoft.com/office/drawing/2014/main" id="{4AC00E66-F6DE-4763-C5D1-6A285C8F48AC}"/>
                 </a:ext>
               </a:extLst>
             </p:cNvPr>
-            <p:cNvSpPr/>
+            <p:cNvSpPr txBox="1"/>
             <p:nvPr/>
           </p:nvSpPr>
           <p:spPr>
             <a:xfrm>
-              <a:off x="3911748" y="2308781"/>
-              <a:ext cx="914400" cy="296148"/>
+              <a:off x="5446248" y="1630137"/>
+              <a:ext cx="571375" cy="584775"/>
             </a:xfrm>
             <a:prstGeom prst="rect">
               <a:avLst/>
             </a:prstGeom>
             <a:noFill/>
           </p:spPr>
-          <p:style>
-            <a:lnRef idx="2">
-              <a:schemeClr val="accent1">
-                <a:shade val="15000"/>
-              </a:schemeClr>
-            </a:lnRef>
-            <a:fillRef idx="1">
-              <a:schemeClr val="accent1"/>
-            </a:fillRef>
-            <a:effectRef idx="0">
-              <a:schemeClr val="accent1"/>
-            </a:effectRef>
-            <a:fontRef idx="minor">
-              <a:schemeClr val="lt1"/>
-            </a:fontRef>
-          </p:style>
           <p:txBody>
-            <a:bodyPr rtlCol="0" anchor="ctr"/>
+            <a:bodyPr wrap="none" rtlCol="0">
+              <a:spAutoFit/>
+            </a:bodyPr>
             <a:lstStyle/>
             <a:p>
-              <a:pPr algn="ctr"/>
-              <a:endParaRPr lang="en-US"/>
+              <a:r>
+                <a:rPr lang="en-US" sz="1600" dirty="0">
+                  <a:solidFill>
+                    <a:srgbClr val="00B050"/>
+                  </a:solidFill>
+                </a:rPr>
+                <a:t>Data</a:t>
+              </a:r>
+              <a:br>
+                <a:rPr lang="en-US" sz="1600" dirty="0">
+                  <a:solidFill>
+                    <a:srgbClr val="00B050"/>
+                  </a:solidFill>
+                </a:rPr>
+              </a:br>
+              <a:r>
+                <a:rPr lang="en-US" sz="1600" dirty="0">
+                  <a:solidFill>
+                    <a:srgbClr val="00B050"/>
+                  </a:solidFill>
+                </a:rPr>
+                <a:t>Bus</a:t>
+              </a:r>
             </a:p>
           </p:txBody>
         </p:sp>
-        <p:cxnSp>
-          <p:nvCxnSpPr>
-            <p:cNvPr id="70" name="Straight Arrow Connector 69">
+        <p:grpSp>
+          <p:nvGrpSpPr>
+            <p:cNvPr id="62" name="Group 61">
               <a:extLst>
                 <a:ext uri="{FF2B5EF4-FFF2-40B4-BE49-F238E27FC236}">
-                  <a16:creationId xmlns:a16="http://schemas.microsoft.com/office/drawing/2014/main" id="{F702F6A0-4640-7363-F51D-D58887326223}"/>
+                  <a16:creationId xmlns:a16="http://schemas.microsoft.com/office/drawing/2014/main" id="{03BE214C-0C61-D9C3-A14A-90EFDFD19676}"/>
                 </a:ext>
               </a:extLst>
             </p:cNvPr>
-            <p:cNvCxnSpPr/>
+            <p:cNvGrpSpPr/>
             <p:nvPr/>
-          </p:nvCxnSpPr>
-          <p:spPr>
+          </p:nvGrpSpPr>
+          <p:grpSpPr>
             <a:xfrm>
-              <a:off x="4826148" y="2507810"/>
-              <a:ext cx="738563" cy="0"/>
+              <a:off x="3163502" y="2605830"/>
+              <a:ext cx="2397325" cy="296148"/>
+              <a:chOff x="3167386" y="2308781"/>
+              <a:chExt cx="2397325" cy="296148"/>
             </a:xfrm>
-            <a:prstGeom prst="straightConnector1">
-              <a:avLst/>
-            </a:prstGeom>
-            <a:ln>
-              <a:solidFill>
-                <a:srgbClr val="00B050"/>
-              </a:solidFill>
-              <a:headEnd type="triangle"/>
-              <a:tailEnd type="triangle"/>
-            </a:ln>
-          </p:spPr>
-          <p:style>
-            <a:lnRef idx="1">
-              <a:schemeClr val="accent1"/>
-            </a:lnRef>
-            <a:fillRef idx="0">
-              <a:schemeClr val="accent1"/>
-            </a:fillRef>
-            <a:effectRef idx="0">
-              <a:schemeClr val="accent1"/>
-            </a:effectRef>
-            <a:fontRef idx="minor">
-              <a:schemeClr val="tx1"/>
-            </a:fontRef>
-          </p:style>
-        </p:cxnSp>
-        <p:cxnSp>
-          <p:nvCxnSpPr>
-            <p:cNvPr id="71" name="Straight Arrow Connector 70">
-              <a:extLst>
-                <a:ext uri="{FF2B5EF4-FFF2-40B4-BE49-F238E27FC236}">
-                  <a16:creationId xmlns:a16="http://schemas.microsoft.com/office/drawing/2014/main" id="{5A26EBD6-192A-69F0-C19C-2D891FD30917}"/>
-                </a:ext>
-              </a:extLst>
-            </p:cNvPr>
-            <p:cNvCxnSpPr>
-              <a:cxnSpLocks/>
-            </p:cNvCxnSpPr>
-            <p:nvPr/>
-          </p:nvCxnSpPr>
-          <p:spPr>
-            <a:xfrm flipH="1">
-              <a:off x="4826148" y="2406103"/>
-              <a:ext cx="381245" cy="0"/>
-            </a:xfrm>
-            <a:prstGeom prst="straightConnector1">
-              <a:avLst/>
-            </a:prstGeom>
-            <a:ln>
-              <a:tailEnd type="triangle"/>
-            </a:ln>
-          </p:spPr>
-          <p:style>
-            <a:lnRef idx="1">
-              <a:schemeClr val="accent1"/>
-            </a:lnRef>
-            <a:fillRef idx="0">
-              <a:schemeClr val="accent1"/>
-            </a:fillRef>
-            <a:effectRef idx="0">
-              <a:schemeClr val="accent1"/>
-            </a:effectRef>
-            <a:fontRef idx="minor">
-              <a:schemeClr val="tx1"/>
-            </a:fontRef>
-          </p:style>
-        </p:cxnSp>
-      </p:grpSp>
-      <mc:AlternateContent xmlns:mc="http://schemas.openxmlformats.org/markup-compatibility/2006" xmlns:a14="http://schemas.microsoft.com/office/drawing/2010/main">
-        <mc:Choice Requires="a14">
-          <p:sp>
-            <p:nvSpPr>
-              <p:cNvPr id="81" name="TextBox 80">
+          </p:grpSpPr>
+          <p:cxnSp>
+            <p:nvCxnSpPr>
+              <p:cNvPr id="63" name="Straight Arrow Connector 62">
                 <a:extLst>
                   <a:ext uri="{FF2B5EF4-FFF2-40B4-BE49-F238E27FC236}">
-                    <a16:creationId xmlns:a16="http://schemas.microsoft.com/office/drawing/2014/main" id="{36684B7C-11A2-5520-A488-D3CE9499C79E}"/>
+                    <a16:creationId xmlns:a16="http://schemas.microsoft.com/office/drawing/2014/main" id="{92A9608B-D09E-FC52-42A7-1255BEB8CDD5}"/>
                   </a:ext>
                 </a:extLst>
               </p:cNvPr>
-              <p:cNvSpPr txBox="1"/>
+              <p:cNvCxnSpPr/>
+              <p:nvPr/>
+            </p:nvCxnSpPr>
+            <p:spPr>
+              <a:xfrm>
+                <a:off x="3167386" y="2472526"/>
+                <a:ext cx="738563" cy="0"/>
+              </a:xfrm>
+              <a:prstGeom prst="straightConnector1">
+                <a:avLst/>
+              </a:prstGeom>
+              <a:ln>
+                <a:solidFill>
+                  <a:schemeClr val="accent6">
+                    <a:lumMod val="75000"/>
+                  </a:schemeClr>
+                </a:solidFill>
+                <a:tailEnd type="triangle"/>
+              </a:ln>
+            </p:spPr>
+            <p:style>
+              <a:lnRef idx="1">
+                <a:schemeClr val="accent1"/>
+              </a:lnRef>
+              <a:fillRef idx="0">
+                <a:schemeClr val="accent1"/>
+              </a:fillRef>
+              <a:effectRef idx="0">
+                <a:schemeClr val="accent1"/>
+              </a:effectRef>
+              <a:fontRef idx="minor">
+                <a:schemeClr val="tx1"/>
+              </a:fontRef>
+            </p:style>
+          </p:cxnSp>
+          <p:sp>
+            <p:nvSpPr>
+              <p:cNvPr id="64" name="Rectangle 63">
+                <a:extLst>
+                  <a:ext uri="{FF2B5EF4-FFF2-40B4-BE49-F238E27FC236}">
+                    <a16:creationId xmlns:a16="http://schemas.microsoft.com/office/drawing/2014/main" id="{B76BA245-15FD-6781-181D-1D5F2E63E6A2}"/>
+                  </a:ext>
+                </a:extLst>
+              </p:cNvPr>
+              <p:cNvSpPr/>
               <p:nvPr/>
             </p:nvSpPr>
             <p:spPr>
               <a:xfrm>
-                <a:off x="3951413" y="1708762"/>
-                <a:ext cx="800797" cy="584775"/>
+                <a:off x="3911748" y="2308781"/>
+                <a:ext cx="914400" cy="296148"/>
               </a:xfrm>
               <a:prstGeom prst="rect">
                 <a:avLst/>
               </a:prstGeom>
               <a:noFill/>
             </p:spPr>
+            <p:style>
+              <a:lnRef idx="2">
+                <a:schemeClr val="accent1">
+                  <a:shade val="15000"/>
+                </a:schemeClr>
+              </a:lnRef>
+              <a:fillRef idx="1">
+                <a:schemeClr val="accent1"/>
+              </a:fillRef>
+              <a:effectRef idx="0">
+                <a:schemeClr val="accent1"/>
+              </a:effectRef>
+              <a:fontRef idx="minor">
+                <a:schemeClr val="lt1"/>
+              </a:fontRef>
+            </p:style>
             <p:txBody>
-              <a:bodyPr wrap="none" rtlCol="0">
-                <a:spAutoFit/>
-              </a:bodyPr>
+              <a:bodyPr rtlCol="0" anchor="ctr"/>
               <a:lstStyle/>
               <a:p>
-                <a14:m>
-                  <m:oMath xmlns:m="http://schemas.openxmlformats.org/officeDocument/2006/math">
-                    <m:r>
-                      <a:rPr lang="en-US" sz="1600" b="0" i="1" smtClean="0">
-                        <a:solidFill>
-                          <a:schemeClr val="accent2">
-                            <a:lumMod val="75000"/>
-                          </a:schemeClr>
-                        </a:solidFill>
-                        <a:latin typeface="Cambria Math" panose="02040503050406030204" pitchFamily="18" charset="0"/>
-                      </a:rPr>
-                      <m:t>𝑁</m:t>
-                    </m:r>
-                  </m:oMath>
-                </a14:m>
-                <a:r>
-                  <a:rPr lang="en-US" sz="1600" dirty="0">
-                    <a:solidFill>
-                      <a:schemeClr val="accent2">
-                        <a:lumMod val="75000"/>
-                      </a:schemeClr>
-                    </a:solidFill>
-                  </a:rPr>
-                  <a:t> data </a:t>
-                </a:r>
-                <a:br>
-                  <a:rPr lang="en-US" sz="1600" dirty="0">
-                    <a:solidFill>
-                      <a:schemeClr val="accent2">
-                        <a:lumMod val="75000"/>
-                      </a:schemeClr>
-                    </a:solidFill>
-                  </a:rPr>
-                </a:br>
-                <a:r>
-                  <a:rPr lang="en-US" sz="1600" dirty="0">
-                    <a:solidFill>
-                      <a:schemeClr val="accent2">
-                        <a:lumMod val="75000"/>
-                      </a:schemeClr>
-                    </a:solidFill>
-                  </a:rPr>
-                  <a:t>words</a:t>
-                </a:r>
+                <a:pPr algn="ctr"/>
+                <a:endParaRPr lang="en-US"/>
               </a:p>
             </p:txBody>
           </p:sp>
-        </mc:Choice>
-        <mc:Fallback xmlns="">
-          <p:sp>
-            <p:nvSpPr>
-              <p:cNvPr id="81" name="TextBox 80">
+          <p:cxnSp>
+            <p:nvCxnSpPr>
+              <p:cNvPr id="65" name="Straight Arrow Connector 64">
                 <a:extLst>
                   <a:ext uri="{FF2B5EF4-FFF2-40B4-BE49-F238E27FC236}">
-                    <a16:creationId xmlns:a16="http://schemas.microsoft.com/office/drawing/2014/main" id="{36684B7C-11A2-5520-A488-D3CE9499C79E}"/>
+                    <a16:creationId xmlns:a16="http://schemas.microsoft.com/office/drawing/2014/main" id="{3769AB36-0F08-C5FE-886B-6B7DEE6DEAEC}"/>
                   </a:ext>
                 </a:extLst>
               </p:cNvPr>
-              <p:cNvSpPr txBox="1">
-                <a:spLocks noRot="1" noChangeAspect="1" noMove="1" noResize="1" noEditPoints="1" noAdjustHandles="1" noChangeArrowheads="1" noChangeShapeType="1" noTextEdit="1"/>
-              </p:cNvSpPr>
+              <p:cNvCxnSpPr/>
+              <p:nvPr/>
+            </p:nvCxnSpPr>
+            <p:spPr>
+              <a:xfrm>
+                <a:off x="4826148" y="2507810"/>
+                <a:ext cx="738563" cy="0"/>
+              </a:xfrm>
+              <a:prstGeom prst="straightConnector1">
+                <a:avLst/>
+              </a:prstGeom>
+              <a:ln>
+                <a:solidFill>
+                  <a:srgbClr val="00B050"/>
+                </a:solidFill>
+                <a:headEnd type="triangle"/>
+                <a:tailEnd type="triangle"/>
+              </a:ln>
+            </p:spPr>
+            <p:style>
+              <a:lnRef idx="1">
+                <a:schemeClr val="accent1"/>
+              </a:lnRef>
+              <a:fillRef idx="0">
+                <a:schemeClr val="accent1"/>
+              </a:fillRef>
+              <a:effectRef idx="0">
+                <a:schemeClr val="accent1"/>
+              </a:effectRef>
+              <a:fontRef idx="minor">
+                <a:schemeClr val="tx1"/>
+              </a:fontRef>
+            </p:style>
+          </p:cxnSp>
+          <p:cxnSp>
+            <p:nvCxnSpPr>
+              <p:cNvPr id="66" name="Straight Arrow Connector 65">
+                <a:extLst>
+                  <a:ext uri="{FF2B5EF4-FFF2-40B4-BE49-F238E27FC236}">
+                    <a16:creationId xmlns:a16="http://schemas.microsoft.com/office/drawing/2014/main" id="{A2061DEC-B635-5343-3CA1-DEC6B0902FC0}"/>
+                  </a:ext>
+                </a:extLst>
+              </p:cNvPr>
+              <p:cNvCxnSpPr>
+                <a:cxnSpLocks/>
+              </p:cNvCxnSpPr>
+              <p:nvPr/>
+            </p:nvCxnSpPr>
+            <p:spPr>
+              <a:xfrm flipH="1">
+                <a:off x="4826148" y="2406103"/>
+                <a:ext cx="381245" cy="0"/>
+              </a:xfrm>
+              <a:prstGeom prst="straightConnector1">
+                <a:avLst/>
+              </a:prstGeom>
+              <a:ln>
+                <a:tailEnd type="triangle"/>
+              </a:ln>
+            </p:spPr>
+            <p:style>
+              <a:lnRef idx="1">
+                <a:schemeClr val="accent1"/>
+              </a:lnRef>
+              <a:fillRef idx="0">
+                <a:schemeClr val="accent1"/>
+              </a:fillRef>
+              <a:effectRef idx="0">
+                <a:schemeClr val="accent1"/>
+              </a:effectRef>
+              <a:fontRef idx="minor">
+                <a:schemeClr val="tx1"/>
+              </a:fontRef>
+            </p:style>
+          </p:cxnSp>
+        </p:grpSp>
+        <p:grpSp>
+          <p:nvGrpSpPr>
+            <p:cNvPr id="67" name="Group 66">
+              <a:extLst>
+                <a:ext uri="{FF2B5EF4-FFF2-40B4-BE49-F238E27FC236}">
+                  <a16:creationId xmlns:a16="http://schemas.microsoft.com/office/drawing/2014/main" id="{23C15D42-54C0-8F3D-9D02-372FD33F0E9D}"/>
+                </a:ext>
+              </a:extLst>
+            </p:cNvPr>
+            <p:cNvGrpSpPr/>
+            <p:nvPr/>
+          </p:nvGrpSpPr>
+          <p:grpSpPr>
+            <a:xfrm>
+              <a:off x="3150250" y="4652701"/>
+              <a:ext cx="2397325" cy="296148"/>
+              <a:chOff x="3167386" y="2308781"/>
+              <a:chExt cx="2397325" cy="296148"/>
+            </a:xfrm>
+          </p:grpSpPr>
+          <p:cxnSp>
+            <p:nvCxnSpPr>
+              <p:cNvPr id="68" name="Straight Arrow Connector 67">
+                <a:extLst>
+                  <a:ext uri="{FF2B5EF4-FFF2-40B4-BE49-F238E27FC236}">
+                    <a16:creationId xmlns:a16="http://schemas.microsoft.com/office/drawing/2014/main" id="{844380C4-92E7-0497-592B-77D939FED30B}"/>
+                  </a:ext>
+                </a:extLst>
+              </p:cNvPr>
+              <p:cNvCxnSpPr/>
+              <p:nvPr/>
+            </p:nvCxnSpPr>
+            <p:spPr>
+              <a:xfrm>
+                <a:off x="3167386" y="2472526"/>
+                <a:ext cx="738563" cy="0"/>
+              </a:xfrm>
+              <a:prstGeom prst="straightConnector1">
+                <a:avLst/>
+              </a:prstGeom>
+              <a:ln>
+                <a:solidFill>
+                  <a:schemeClr val="accent6">
+                    <a:lumMod val="75000"/>
+                  </a:schemeClr>
+                </a:solidFill>
+                <a:tailEnd type="triangle"/>
+              </a:ln>
+            </p:spPr>
+            <p:style>
+              <a:lnRef idx="1">
+                <a:schemeClr val="accent1"/>
+              </a:lnRef>
+              <a:fillRef idx="0">
+                <a:schemeClr val="accent1"/>
+              </a:fillRef>
+              <a:effectRef idx="0">
+                <a:schemeClr val="accent1"/>
+              </a:effectRef>
+              <a:fontRef idx="minor">
+                <a:schemeClr val="tx1"/>
+              </a:fontRef>
+            </p:style>
+          </p:cxnSp>
+          <p:sp>
+            <p:nvSpPr>
+              <p:cNvPr id="69" name="Rectangle 68">
+                <a:extLst>
+                  <a:ext uri="{FF2B5EF4-FFF2-40B4-BE49-F238E27FC236}">
+                    <a16:creationId xmlns:a16="http://schemas.microsoft.com/office/drawing/2014/main" id="{E9ADA6A9-A770-B752-D749-F9DA004178AB}"/>
+                  </a:ext>
+                </a:extLst>
+              </p:cNvPr>
+              <p:cNvSpPr/>
               <p:nvPr/>
             </p:nvSpPr>
             <p:spPr>
               <a:xfrm>
-                <a:off x="3951413" y="1708762"/>
-                <a:ext cx="800797" cy="584775"/>
+                <a:off x="3911748" y="2308781"/>
+                <a:ext cx="914400" cy="296148"/>
               </a:xfrm>
               <a:prstGeom prst="rect">
                 <a:avLst/>
               </a:prstGeom>
-              <a:blipFill>
-                <a:blip r:embed="rId8"/>
-                <a:stretch>
-                  <a:fillRect l="-3788" t="-3125" r="-3030" b="-12500"/>
-                </a:stretch>
-              </a:blipFill>
+              <a:noFill/>
             </p:spPr>
+            <p:style>
+              <a:lnRef idx="2">
+                <a:schemeClr val="accent1">
+                  <a:shade val="15000"/>
+                </a:schemeClr>
+              </a:lnRef>
+              <a:fillRef idx="1">
+                <a:schemeClr val="accent1"/>
+              </a:fillRef>
+              <a:effectRef idx="0">
+                <a:schemeClr val="accent1"/>
+              </a:effectRef>
+              <a:fontRef idx="minor">
+                <a:schemeClr val="lt1"/>
+              </a:fontRef>
+            </p:style>
             <p:txBody>
-              <a:bodyPr/>
+              <a:bodyPr rtlCol="0" anchor="ctr"/>
               <a:lstStyle/>
               <a:p>
-                <a:r>
-                  <a:rPr lang="en-US">
-                    <a:noFill/>
-                  </a:rPr>
-                  <a:t> </a:t>
-                </a:r>
+                <a:pPr algn="ctr"/>
+                <a:endParaRPr lang="en-US"/>
               </a:p>
             </p:txBody>
           </p:sp>
-        </mc:Fallback>
-      </mc:AlternateContent>
-      <p:sp>
-        <p:nvSpPr>
-          <p:cNvPr id="82" name="TextBox 81">
-            <a:extLst>
-              <a:ext uri="{FF2B5EF4-FFF2-40B4-BE49-F238E27FC236}">
-                <a16:creationId xmlns:a16="http://schemas.microsoft.com/office/drawing/2014/main" id="{4115A449-FFD7-3923-3F8F-BDBB90560A3B}"/>
-              </a:ext>
-            </a:extLst>
-          </p:cNvPr>
-          <p:cNvSpPr txBox="1"/>
-          <p:nvPr/>
-        </p:nvSpPr>
-        <p:spPr>
-          <a:xfrm>
-            <a:off x="4906650" y="1851863"/>
-            <a:ext cx="558166" cy="338554"/>
-          </a:xfrm>
-          <a:prstGeom prst="rect">
-            <a:avLst/>
-          </a:prstGeom>
-          <a:noFill/>
-        </p:spPr>
-        <p:txBody>
-          <a:bodyPr wrap="none" rtlCol="0">
-            <a:spAutoFit/>
-          </a:bodyPr>
-          <a:lstStyle/>
-          <a:p>
-            <a:r>
-              <a:rPr lang="en-US" sz="1600" dirty="0">
+          <p:cxnSp>
+            <p:nvCxnSpPr>
+              <p:cNvPr id="70" name="Straight Arrow Connector 69">
+                <a:extLst>
+                  <a:ext uri="{FF2B5EF4-FFF2-40B4-BE49-F238E27FC236}">
+                    <a16:creationId xmlns:a16="http://schemas.microsoft.com/office/drawing/2014/main" id="{F702F6A0-4640-7363-F51D-D58887326223}"/>
+                  </a:ext>
+                </a:extLst>
+              </p:cNvPr>
+              <p:cNvCxnSpPr/>
+              <p:nvPr/>
+            </p:nvCxnSpPr>
+            <p:spPr>
+              <a:xfrm>
+                <a:off x="4826148" y="2507810"/>
+                <a:ext cx="738563" cy="0"/>
+              </a:xfrm>
+              <a:prstGeom prst="straightConnector1">
+                <a:avLst/>
+              </a:prstGeom>
+              <a:ln>
                 <a:solidFill>
-                  <a:schemeClr val="accent2">
-                    <a:lumMod val="75000"/>
-                  </a:schemeClr>
+                  <a:srgbClr val="00B050"/>
                 </a:solidFill>
-              </a:rPr>
-              <a:t>R/W</a:t>
-            </a:r>
-          </a:p>
-        </p:txBody>
-      </p:sp>
+                <a:headEnd type="triangle"/>
+                <a:tailEnd type="triangle"/>
+              </a:ln>
+            </p:spPr>
+            <p:style>
+              <a:lnRef idx="1">
+                <a:schemeClr val="accent1"/>
+              </a:lnRef>
+              <a:fillRef idx="0">
+                <a:schemeClr val="accent1"/>
+              </a:fillRef>
+              <a:effectRef idx="0">
+                <a:schemeClr val="accent1"/>
+              </a:effectRef>
+              <a:fontRef idx="minor">
+                <a:schemeClr val="tx1"/>
+              </a:fontRef>
+            </p:style>
+          </p:cxnSp>
+          <p:cxnSp>
+            <p:nvCxnSpPr>
+              <p:cNvPr id="71" name="Straight Arrow Connector 70">
+                <a:extLst>
+                  <a:ext uri="{FF2B5EF4-FFF2-40B4-BE49-F238E27FC236}">
+                    <a16:creationId xmlns:a16="http://schemas.microsoft.com/office/drawing/2014/main" id="{5A26EBD6-192A-69F0-C19C-2D891FD30917}"/>
+                  </a:ext>
+                </a:extLst>
+              </p:cNvPr>
+              <p:cNvCxnSpPr>
+                <a:cxnSpLocks/>
+              </p:cNvCxnSpPr>
+              <p:nvPr/>
+            </p:nvCxnSpPr>
+            <p:spPr>
+              <a:xfrm flipH="1">
+                <a:off x="4826148" y="2406103"/>
+                <a:ext cx="381245" cy="0"/>
+              </a:xfrm>
+              <a:prstGeom prst="straightConnector1">
+                <a:avLst/>
+              </a:prstGeom>
+              <a:ln>
+                <a:tailEnd type="triangle"/>
+              </a:ln>
+            </p:spPr>
+            <p:style>
+              <a:lnRef idx="1">
+                <a:schemeClr val="accent1"/>
+              </a:lnRef>
+              <a:fillRef idx="0">
+                <a:schemeClr val="accent1"/>
+              </a:fillRef>
+              <a:effectRef idx="0">
+                <a:schemeClr val="accent1"/>
+              </a:effectRef>
+              <a:fontRef idx="minor">
+                <a:schemeClr val="tx1"/>
+              </a:fontRef>
+            </p:style>
+          </p:cxnSp>
+        </p:grpSp>
+        <mc:AlternateContent xmlns:mc="http://schemas.openxmlformats.org/markup-compatibility/2006">
+          <mc:Choice xmlns:a14="http://schemas.microsoft.com/office/drawing/2010/main" Requires="a14">
+            <p:sp>
+              <p:nvSpPr>
+                <p:cNvPr id="81" name="TextBox 80">
+                  <a:extLst>
+                    <a:ext uri="{FF2B5EF4-FFF2-40B4-BE49-F238E27FC236}">
+                      <a16:creationId xmlns:a16="http://schemas.microsoft.com/office/drawing/2014/main" id="{36684B7C-11A2-5520-A488-D3CE9499C79E}"/>
+                    </a:ext>
+                  </a:extLst>
+                </p:cNvPr>
+                <p:cNvSpPr txBox="1"/>
+                <p:nvPr/>
+              </p:nvSpPr>
+              <p:spPr>
+                <a:xfrm>
+                  <a:off x="3951413" y="1708762"/>
+                  <a:ext cx="800797" cy="584775"/>
+                </a:xfrm>
+                <a:prstGeom prst="rect">
+                  <a:avLst/>
+                </a:prstGeom>
+                <a:noFill/>
+              </p:spPr>
+              <p:txBody>
+                <a:bodyPr wrap="none" rtlCol="0">
+                  <a:spAutoFit/>
+                </a:bodyPr>
+                <a:lstStyle/>
+                <a:p>
+                  <a14:m>
+                    <m:oMath xmlns:m="http://schemas.openxmlformats.org/officeDocument/2006/math">
+                      <m:r>
+                        <a:rPr lang="en-US" sz="1600" b="0" i="1" smtClean="0">
+                          <a:solidFill>
+                            <a:schemeClr val="accent2">
+                              <a:lumMod val="75000"/>
+                            </a:schemeClr>
+                          </a:solidFill>
+                          <a:latin typeface="Cambria Math" panose="02040503050406030204" pitchFamily="18" charset="0"/>
+                        </a:rPr>
+                        <m:t>𝑁</m:t>
+                      </m:r>
+                    </m:oMath>
+                  </a14:m>
+                  <a:r>
+                    <a:rPr lang="en-US" sz="1600" dirty="0">
+                      <a:solidFill>
+                        <a:schemeClr val="accent2">
+                          <a:lumMod val="75000"/>
+                        </a:schemeClr>
+                      </a:solidFill>
+                    </a:rPr>
+                    <a:t> data </a:t>
+                  </a:r>
+                  <a:br>
+                    <a:rPr lang="en-US" sz="1600" dirty="0">
+                      <a:solidFill>
+                        <a:schemeClr val="accent2">
+                          <a:lumMod val="75000"/>
+                        </a:schemeClr>
+                      </a:solidFill>
+                    </a:rPr>
+                  </a:br>
+                  <a:r>
+                    <a:rPr lang="en-US" sz="1600" dirty="0">
+                      <a:solidFill>
+                        <a:schemeClr val="accent2">
+                          <a:lumMod val="75000"/>
+                        </a:schemeClr>
+                      </a:solidFill>
+                    </a:rPr>
+                    <a:t>words</a:t>
+                  </a:r>
+                </a:p>
+              </p:txBody>
+            </p:sp>
+          </mc:Choice>
+          <mc:Fallback>
+            <p:sp>
+              <p:nvSpPr>
+                <p:cNvPr id="81" name="TextBox 80">
+                  <a:extLst>
+                    <a:ext uri="{FF2B5EF4-FFF2-40B4-BE49-F238E27FC236}">
+                      <a16:creationId xmlns:a16="http://schemas.microsoft.com/office/drawing/2014/main" id="{36684B7C-11A2-5520-A488-D3CE9499C79E}"/>
+                    </a:ext>
+                  </a:extLst>
+                </p:cNvPr>
+                <p:cNvSpPr txBox="1">
+                  <a:spLocks noRot="1" noChangeAspect="1" noMove="1" noResize="1" noEditPoints="1" noAdjustHandles="1" noChangeArrowheads="1" noChangeShapeType="1" noTextEdit="1"/>
+                </p:cNvSpPr>
+                <p:nvPr/>
+              </p:nvSpPr>
+              <p:spPr>
+                <a:xfrm>
+                  <a:off x="3951413" y="1708762"/>
+                  <a:ext cx="800797" cy="584775"/>
+                </a:xfrm>
+                <a:prstGeom prst="rect">
+                  <a:avLst/>
+                </a:prstGeom>
+                <a:blipFill>
+                  <a:blip r:embed="rId8"/>
+                  <a:stretch>
+                    <a:fillRect l="-3788" t="-3125" r="-3030" b="-12500"/>
+                  </a:stretch>
+                </a:blipFill>
+              </p:spPr>
+              <p:txBody>
+                <a:bodyPr/>
+                <a:lstStyle/>
+                <a:p>
+                  <a:r>
+                    <a:rPr lang="en-US">
+                      <a:noFill/>
+                    </a:rPr>
+                    <a:t> </a:t>
+                  </a:r>
+                </a:p>
+              </p:txBody>
+            </p:sp>
+          </mc:Fallback>
+        </mc:AlternateContent>
+        <p:sp>
+          <p:nvSpPr>
+            <p:cNvPr id="82" name="TextBox 81">
+              <a:extLst>
+                <a:ext uri="{FF2B5EF4-FFF2-40B4-BE49-F238E27FC236}">
+                  <a16:creationId xmlns:a16="http://schemas.microsoft.com/office/drawing/2014/main" id="{4115A449-FFD7-3923-3F8F-BDBB90560A3B}"/>
+                </a:ext>
+              </a:extLst>
+            </p:cNvPr>
+            <p:cNvSpPr txBox="1"/>
+            <p:nvPr/>
+          </p:nvSpPr>
+          <p:spPr>
+            <a:xfrm>
+              <a:off x="4906650" y="1851863"/>
+              <a:ext cx="558166" cy="338554"/>
+            </a:xfrm>
+            <a:prstGeom prst="rect">
+              <a:avLst/>
+            </a:prstGeom>
+            <a:noFill/>
+          </p:spPr>
+          <p:txBody>
+            <a:bodyPr wrap="none" rtlCol="0">
+              <a:spAutoFit/>
+            </a:bodyPr>
+            <a:lstStyle/>
+            <a:p>
+              <a:r>
+                <a:rPr lang="en-US" sz="1600" dirty="0">
+                  <a:solidFill>
+                    <a:schemeClr val="accent2">
+                      <a:lumMod val="75000"/>
+                    </a:schemeClr>
+                  </a:solidFill>
+                </a:rPr>
+                <a:t>R/W</a:t>
+              </a:r>
+            </a:p>
+          </p:txBody>
+        </p:sp>
+      </p:grpSp>
     </p:spTree>
     <p:extLst>
       <p:ext uri="{BB962C8B-B14F-4D97-AF65-F5344CB8AC3E}">

</xml_diff>